<commit_message>
Credit team MISIS X and its participants on presentation title slide
</commit_message>
<xml_diff>
--- a/artifacts/presentation.pptx
+++ b/artifacts/presentation.pptx
@@ -2,33 +2,33 @@
 <file path=ppt/presentation.xml><?xml version="1.0" encoding="utf-8"?>
 <p:presentation xmlns:p="http://schemas.openxmlformats.org/presentationml/2006/main">
   <p:sldMasterIdLst>
-    <p:sldMasterId xmlns:r="http://schemas.openxmlformats.org/officeDocument/2006/relationships" id="2147483648" r:id="R98ef870035fc42e4"/>
+    <p:sldMasterId xmlns:r="http://schemas.openxmlformats.org/officeDocument/2006/relationships" id="2147483648" r:id="R4c7e7d2928fa4e20"/>
   </p:sldMasterIdLst>
   <p:notesMasterIdLst>
-    <p:notesMasterId xmlns:r="http://schemas.openxmlformats.org/officeDocument/2006/relationships" r:id="R84c98e8b6bf5400a"/>
+    <p:notesMasterId xmlns:r="http://schemas.openxmlformats.org/officeDocument/2006/relationships" r:id="R0c92a5ab789743be"/>
   </p:notesMasterIdLst>
   <p:sldIdLst>
-    <p:sldId xmlns:r="http://schemas.openxmlformats.org/officeDocument/2006/relationships" id="256" r:id="Rf8ebda1a42bb48c9"/>
-    <p:sldId xmlns:r="http://schemas.openxmlformats.org/officeDocument/2006/relationships" id="257" r:id="Re7b84f4af578402b"/>
-    <p:sldId xmlns:r="http://schemas.openxmlformats.org/officeDocument/2006/relationships" id="258" r:id="R2cbf895420fa4e90"/>
-    <p:sldId xmlns:r="http://schemas.openxmlformats.org/officeDocument/2006/relationships" id="259" r:id="Rdad5bd3d1c9f44b0"/>
-    <p:sldId xmlns:r="http://schemas.openxmlformats.org/officeDocument/2006/relationships" id="260" r:id="R78f5f5132bf84cf0"/>
-    <p:sldId xmlns:r="http://schemas.openxmlformats.org/officeDocument/2006/relationships" id="261" r:id="R36af2381c15645ca"/>
-    <p:sldId xmlns:r="http://schemas.openxmlformats.org/officeDocument/2006/relationships" id="262" r:id="R47c65a55e0614c37"/>
-    <p:sldId xmlns:r="http://schemas.openxmlformats.org/officeDocument/2006/relationships" id="263" r:id="Rdd3fe14dc3d04130"/>
-    <p:sldId xmlns:r="http://schemas.openxmlformats.org/officeDocument/2006/relationships" id="264" r:id="R3addeb948c4e42f5"/>
-    <p:sldId xmlns:r="http://schemas.openxmlformats.org/officeDocument/2006/relationships" id="265" r:id="Rfddbf0e01d3240f4"/>
-    <p:sldId xmlns:r="http://schemas.openxmlformats.org/officeDocument/2006/relationships" id="266" r:id="R2814f1d58d934808"/>
-    <p:sldId xmlns:r="http://schemas.openxmlformats.org/officeDocument/2006/relationships" id="267" r:id="Rdad4fb2045ca4e99"/>
-    <p:sldId xmlns:r="http://schemas.openxmlformats.org/officeDocument/2006/relationships" id="268" r:id="Rc605a90195f64f12"/>
-    <p:sldId xmlns:r="http://schemas.openxmlformats.org/officeDocument/2006/relationships" id="269" r:id="R79aa823696b04154"/>
-    <p:sldId xmlns:r="http://schemas.openxmlformats.org/officeDocument/2006/relationships" id="270" r:id="Rddd47e7d64724d1a"/>
-    <p:sldId xmlns:r="http://schemas.openxmlformats.org/officeDocument/2006/relationships" id="271" r:id="R14d80aee8ef34f89"/>
-    <p:sldId xmlns:r="http://schemas.openxmlformats.org/officeDocument/2006/relationships" id="272" r:id="Rf26f2e712d5f4c01"/>
-    <p:sldId xmlns:r="http://schemas.openxmlformats.org/officeDocument/2006/relationships" id="273" r:id="Re2ecdbac0a6646f5"/>
-    <p:sldId xmlns:r="http://schemas.openxmlformats.org/officeDocument/2006/relationships" id="274" r:id="Rfdeb7863339c4d6c"/>
-    <p:sldId xmlns:r="http://schemas.openxmlformats.org/officeDocument/2006/relationships" id="275" r:id="Rc9233dc61f8b421e"/>
-    <p:sldId xmlns:r="http://schemas.openxmlformats.org/officeDocument/2006/relationships" id="276" r:id="R96c53e52a6b441be"/>
+    <p:sldId xmlns:r="http://schemas.openxmlformats.org/officeDocument/2006/relationships" id="256" r:id="Rdd0b1771827c4eb6"/>
+    <p:sldId xmlns:r="http://schemas.openxmlformats.org/officeDocument/2006/relationships" id="257" r:id="R528689f63080452e"/>
+    <p:sldId xmlns:r="http://schemas.openxmlformats.org/officeDocument/2006/relationships" id="258" r:id="Re8e1728634734800"/>
+    <p:sldId xmlns:r="http://schemas.openxmlformats.org/officeDocument/2006/relationships" id="259" r:id="R5b7d03fa755d4767"/>
+    <p:sldId xmlns:r="http://schemas.openxmlformats.org/officeDocument/2006/relationships" id="260" r:id="R22f80406ce204296"/>
+    <p:sldId xmlns:r="http://schemas.openxmlformats.org/officeDocument/2006/relationships" id="261" r:id="Rf11c78988a3847b3"/>
+    <p:sldId xmlns:r="http://schemas.openxmlformats.org/officeDocument/2006/relationships" id="262" r:id="R076844d28bda4cee"/>
+    <p:sldId xmlns:r="http://schemas.openxmlformats.org/officeDocument/2006/relationships" id="263" r:id="R21c8f8d9a6f94e66"/>
+    <p:sldId xmlns:r="http://schemas.openxmlformats.org/officeDocument/2006/relationships" id="264" r:id="Ra2235403e02b4579"/>
+    <p:sldId xmlns:r="http://schemas.openxmlformats.org/officeDocument/2006/relationships" id="265" r:id="Rc8c232c0b931452c"/>
+    <p:sldId xmlns:r="http://schemas.openxmlformats.org/officeDocument/2006/relationships" id="266" r:id="Rebf4944cdcd84f5f"/>
+    <p:sldId xmlns:r="http://schemas.openxmlformats.org/officeDocument/2006/relationships" id="267" r:id="R1852a9ea7e8f4e69"/>
+    <p:sldId xmlns:r="http://schemas.openxmlformats.org/officeDocument/2006/relationships" id="268" r:id="Rd7c2ad14052e4986"/>
+    <p:sldId xmlns:r="http://schemas.openxmlformats.org/officeDocument/2006/relationships" id="269" r:id="Rc74a251e7fb34178"/>
+    <p:sldId xmlns:r="http://schemas.openxmlformats.org/officeDocument/2006/relationships" id="270" r:id="Rbd72c80095ea4638"/>
+    <p:sldId xmlns:r="http://schemas.openxmlformats.org/officeDocument/2006/relationships" id="271" r:id="R4e202b32bde643be"/>
+    <p:sldId xmlns:r="http://schemas.openxmlformats.org/officeDocument/2006/relationships" id="272" r:id="Ra202f9c1572d443d"/>
+    <p:sldId xmlns:r="http://schemas.openxmlformats.org/officeDocument/2006/relationships" id="273" r:id="Rac3e482d46d34ac7"/>
+    <p:sldId xmlns:r="http://schemas.openxmlformats.org/officeDocument/2006/relationships" id="274" r:id="R18454d994fd34d4f"/>
+    <p:sldId xmlns:r="http://schemas.openxmlformats.org/officeDocument/2006/relationships" id="275" r:id="Radd40b418c21405f"/>
+    <p:sldId xmlns:r="http://schemas.openxmlformats.org/officeDocument/2006/relationships" id="276" r:id="R41e3bfe151f5405f"/>
   </p:sldIdLst>
   <p:sldSz cx="12192000" cy="6858000"/>
   <p:notesSz cx="6858000" cy="9144000"/>
@@ -462,7 +462,7 @@
           <a:lstStyle xmlns:a="http://schemas.openxmlformats.org/drawingml/2006/main"/>
           <a:p xmlns:a="http://schemas.openxmlformats.org/drawingml/2006/main">
             <a:r>
-              <a:t>Author handle from repositoryowner, no additionalteamidentityclaimed. QR and native hyperlink target the public single-root submission repository. Viewer hyperlink targets GitHub Pages. Private research repository history is not published. Sources: jury_guide.json andreport. Retrospectivearchive2024, no independent2025facts.</a:t>
+              <a:t>Team identity provided by the user: MISIS X; participants Мещеряков Никита and Соколова Юлия. QR and native hyperlink target the public single-root submission repository. Viewer hyperlink targets GitHub Pages. Private research repository history is not published. Sources: jury_guide.json andreport. Retrospectivearchive2024, no independent2025facts.</a:t>
             </a:r>
           </a:p>
         </p:txBody>
@@ -1930,7 +1930,7 @@
   </p:cSld>
   <p:clrMap bg1="lt1" tx1="dk1" bg2="lt2" tx2="dk2" accent1="accent1" accent2="accent2" accent3="accent3" accent4="accent4" accent5="accent5" accent6="accent6" hlink="hlink" folHlink="folHlink"/>
   <p:sldLayoutIdLst>
-    <p:sldLayoutId xmlns:r="http://schemas.openxmlformats.org/officeDocument/2006/relationships" id="2147483649" r:id="R7673fcf828144471"/>
+    <p:sldLayoutId xmlns:r="http://schemas.openxmlformats.org/officeDocument/2006/relationships" id="2147483649" r:id="R9b4d6219b5d74a93"/>
   </p:sldLayoutIdLst>
   <p:txStyles>
     <p:titleStyle>
@@ -5772,10 +5772,10 @@
       </p:grpSpPr>
       <p:sp>
         <p:nvSpPr>
-          <p:cNvPr id="12" name="">
+          <p:cNvPr id="13" name="">
             <a:extLst xmlns:a="http://schemas.openxmlformats.org/drawingml/2006/main">
               <a:ext uri="{FF2B5EF4-FFF2-40B4-BE49-F238E27FC236}">
-                <a16:creationId xmlns:a16="http://schemas.microsoft.com/office/drawing/2014/main" id="{48F6DDF0-A114-4F9B-8AF0-2522D670A296}"/>
+                <a16:creationId xmlns:a16="http://schemas.microsoft.com/office/drawing/2014/main" id="{60708A03-320E-40EF-A73C-2A929D62CCF1}"/>
               </a:ext>
             </a:extLst>
           </p:cNvPr>
@@ -5855,7 +5855,7 @@
           <p:cNvPr id="2" name="">
             <a:extLst xmlns:a="http://schemas.openxmlformats.org/drawingml/2006/main">
               <a:ext uri="{FF2B5EF4-FFF2-40B4-BE49-F238E27FC236}">
-                <a16:creationId xmlns:a16="http://schemas.microsoft.com/office/drawing/2014/main" id="{1D7A3F92-A3FF-4A9D-B6AE-F9AA1C61BF1F}"/>
+                <a16:creationId xmlns:a16="http://schemas.microsoft.com/office/drawing/2014/main" id="{27B58016-07B8-41FF-82FD-6E78AA247533}"/>
               </a:ext>
             </a:extLst>
           </p:cNvPr>
@@ -5912,7 +5912,7 @@
           <p:cNvPr id="3" name="">
             <a:extLst xmlns:a="http://schemas.openxmlformats.org/drawingml/2006/main">
               <a:ext uri="{FF2B5EF4-FFF2-40B4-BE49-F238E27FC236}">
-                <a16:creationId xmlns:a16="http://schemas.microsoft.com/office/drawing/2014/main" id="{2A52DD71-BDFF-4776-BFD2-A6768ADDCD99}"/>
+                <a16:creationId xmlns:a16="http://schemas.microsoft.com/office/drawing/2014/main" id="{EBC27D95-0E2F-437D-B363-823C18F2B0A1}"/>
               </a:ext>
             </a:extLst>
           </p:cNvPr>
@@ -5969,7 +5969,7 @@
           <p:cNvPr id="4" name="">
             <a:extLst xmlns:a="http://schemas.openxmlformats.org/drawingml/2006/main">
               <a:ext uri="{FF2B5EF4-FFF2-40B4-BE49-F238E27FC236}">
-                <a16:creationId xmlns:a16="http://schemas.microsoft.com/office/drawing/2014/main" id="{1EB0C12A-2880-476A-BF52-5F8CD4D4EDA5}"/>
+                <a16:creationId xmlns:a16="http://schemas.microsoft.com/office/drawing/2014/main" id="{76D1B231-A66E-47F0-8C41-2E668740E7CC}"/>
               </a:ext>
             </a:extLst>
           </p:cNvPr>
@@ -5981,7 +5981,7 @@
         <p:spPr>
           <a:xfrm xmlns:a="http://schemas.openxmlformats.org/drawingml/2006/main">
             <a:off x="609600" y="2333625"/>
-            <a:ext cx="8858250" cy="419100"/>
+            <a:ext cx="8858250" cy="381000"/>
           </a:xfrm>
           <a:prstGeom xmlns:a="http://schemas.openxmlformats.org/drawingml/2006/main" prst="rect">
             <a:avLst/>
@@ -5998,7 +5998,7 @@
           <a:lstStyle xmlns:a="http://schemas.openxmlformats.org/drawingml/2006/main"/>
           <a:p xmlns:a="http://schemas.openxmlformats.org/drawingml/2006/main">
             <a:pPr>
-              <a:defRPr sz="1875" b="0">
+              <a:defRPr sz="2100" b="1">
                 <a:solidFill>
                   <a:srgbClr val="183B32"/>
                 </a:solidFill>
@@ -6008,7 +6008,7 @@
               </a:defRPr>
             </a:pPr>
             <a:r>
-              <a:rPr sz="1875" b="0">
+              <a:rPr sz="2100" b="1">
                 <a:solidFill>
                   <a:srgbClr val="183B32"/>
                 </a:solidFill>
@@ -6016,7 +6016,7 @@
                 <a:ea typeface="Noto Sans"/>
                 <a:cs typeface="Noto Sans"/>
               </a:rPr>
-              <a:t>Автор проекта: NikitaMeshDS</a:t>
+              <a:t>Команда MISIS X</a:t>
             </a:r>
           </a:p>
         </p:txBody>
@@ -6026,7 +6026,64 @@
           <p:cNvPr id="5" name="">
             <a:extLst xmlns:a="http://schemas.openxmlformats.org/drawingml/2006/main">
               <a:ext uri="{FF2B5EF4-FFF2-40B4-BE49-F238E27FC236}">
-                <a16:creationId xmlns:a16="http://schemas.microsoft.com/office/drawing/2014/main" id="{98AA101B-E527-42AC-ADDD-9FCBF8B20287}"/>
+                <a16:creationId xmlns:a16="http://schemas.microsoft.com/office/drawing/2014/main" id="{F059652C-3200-411D-ABFE-8A8DE2BD3595}"/>
+              </a:ext>
+            </a:extLst>
+          </p:cNvPr>
+          <p:cNvSpPr>
+            <a:spLocks xmlns:a="http://schemas.openxmlformats.org/drawingml/2006/main" noGrp="1"/>
+          </p:cNvSpPr>
+          <p:nvPr/>
+        </p:nvSpPr>
+        <p:spPr>
+          <a:xfrm xmlns:a="http://schemas.openxmlformats.org/drawingml/2006/main">
+            <a:off x="609600" y="2733675"/>
+            <a:ext cx="8858250" cy="323850"/>
+          </a:xfrm>
+          <a:prstGeom xmlns:a="http://schemas.openxmlformats.org/drawingml/2006/main" prst="rect">
+            <a:avLst/>
+          </a:prstGeom>
+          <a:noFill xmlns:a="http://schemas.openxmlformats.org/drawingml/2006/main"/>
+          <a:ln xmlns:a="http://schemas.openxmlformats.org/drawingml/2006/main" w="0">
+            <a:noFill/>
+          </a:ln>
+        </p:spPr>
+        <p:txBody>
+          <a:bodyPr xmlns:a="http://schemas.openxmlformats.org/drawingml/2006/main">
+            <a:noAutofit/>
+          </a:bodyPr>
+          <a:lstStyle xmlns:a="http://schemas.openxmlformats.org/drawingml/2006/main"/>
+          <a:p xmlns:a="http://schemas.openxmlformats.org/drawingml/2006/main">
+            <a:pPr>
+              <a:defRPr sz="1725" b="0">
+                <a:solidFill>
+                  <a:srgbClr val="183B32"/>
+                </a:solidFill>
+                <a:latin typeface="Noto Sans"/>
+                <a:ea typeface="Noto Sans"/>
+                <a:cs typeface="Noto Sans"/>
+              </a:defRPr>
+            </a:pPr>
+            <a:r>
+              <a:rPr sz="1725" b="0">
+                <a:solidFill>
+                  <a:srgbClr val="183B32"/>
+                </a:solidFill>
+                <a:latin typeface="Noto Sans"/>
+                <a:ea typeface="Noto Sans"/>
+                <a:cs typeface="Noto Sans"/>
+              </a:rPr>
+              <a:t>Участники: Мещеряков Никита · Соколова Юлия</a:t>
+            </a:r>
+          </a:p>
+        </p:txBody>
+      </p:sp>
+      <p:sp>
+        <p:nvSpPr>
+          <p:cNvPr id="6" name="">
+            <a:extLst xmlns:a="http://schemas.openxmlformats.org/drawingml/2006/main">
+              <a:ext uri="{FF2B5EF4-FFF2-40B4-BE49-F238E27FC236}">
+                <a16:creationId xmlns:a16="http://schemas.microsoft.com/office/drawing/2014/main" id="{2AE1326D-8F78-44C2-8E8D-7EE0AFFEE4DC}"/>
               </a:ext>
             </a:extLst>
           </p:cNvPr>
@@ -6080,10 +6137,10 @@
       </p:sp>
       <p:sp>
         <p:nvSpPr>
-          <p:cNvPr id="6" name="">
+          <p:cNvPr id="7" name="">
             <a:extLst xmlns:a="http://schemas.openxmlformats.org/drawingml/2006/main">
               <a:ext uri="{FF2B5EF4-FFF2-40B4-BE49-F238E27FC236}">
-                <a16:creationId xmlns:a16="http://schemas.microsoft.com/office/drawing/2014/main" id="{BFBC08D5-0EF1-4288-B213-13B7D1E871BF}"/>
+                <a16:creationId xmlns:a16="http://schemas.microsoft.com/office/drawing/2014/main" id="{A95A2CE8-5EC6-4B7E-B11B-D77B2646064D}"/>
               </a:ext>
             </a:extLst>
           </p:cNvPr>
@@ -6160,10 +6217,10 @@
       </p:sp>
       <p:sp>
         <p:nvSpPr>
-          <p:cNvPr id="7" name="">
+          <p:cNvPr id="8" name="">
             <a:extLst xmlns:a="http://schemas.openxmlformats.org/drawingml/2006/main">
               <a:ext uri="{FF2B5EF4-FFF2-40B4-BE49-F238E27FC236}">
-                <a16:creationId xmlns:a16="http://schemas.microsoft.com/office/drawing/2014/main" id="{8791ADD8-AC4E-48A4-937C-278861AA2D8E}"/>
+                <a16:creationId xmlns:a16="http://schemas.microsoft.com/office/drawing/2014/main" id="{B7C6D402-6A3C-4C45-888F-E75D53D5924E}"/>
               </a:ext>
             </a:extLst>
           </p:cNvPr>
@@ -6209,7 +6266,7 @@
                 <a:latin typeface="Noto Sans"/>
                 <a:ea typeface="Noto Sans"/>
                 <a:cs typeface="Noto Sans"/>
-                <a:hlinkClick xmlns:r="http://schemas.openxmlformats.org/officeDocument/2006/relationships" r:id="Rc46484955b9447b8"/>
+                <a:hlinkClick xmlns:r="http://schemas.openxmlformats.org/officeDocument/2006/relationships" r:id="R48d84175b0864ed1"/>
               </a:rPr>
               <a:t>github.com/NikitaMeshDS/sberindex-task2</a:t>
             </a:r>
@@ -6218,10 +6275,10 @@
       </p:sp>
       <p:sp>
         <p:nvSpPr>
-          <p:cNvPr id="8" name="">
+          <p:cNvPr id="9" name="">
             <a:extLst xmlns:a="http://schemas.openxmlformats.org/drawingml/2006/main">
               <a:ext uri="{FF2B5EF4-FFF2-40B4-BE49-F238E27FC236}">
-                <a16:creationId xmlns:a16="http://schemas.microsoft.com/office/drawing/2014/main" id="{5841C003-AA78-4855-9884-54313B6F3F29}"/>
+                <a16:creationId xmlns:a16="http://schemas.microsoft.com/office/drawing/2014/main" id="{87583243-40DF-4BB5-A4F2-020382499267}"/>
               </a:ext>
             </a:extLst>
           </p:cNvPr>
@@ -6267,7 +6324,7 @@
                 <a:latin typeface="Noto Sans"/>
                 <a:ea typeface="Noto Sans"/>
                 <a:cs typeface="Noto Sans"/>
-                <a:hlinkClick xmlns:r="http://schemas.openxmlformats.org/officeDocument/2006/relationships" r:id="R4ccbbe2cfd60433f"/>
+                <a:hlinkClick xmlns:r="http://schemas.openxmlformats.org/officeDocument/2006/relationships" r:id="R1417d7490870419a"/>
               </a:rPr>
               <a:t>nikitameshds.github.io/sberindex-task2</a:t>
             </a:r>
@@ -6276,14 +6333,14 @@
       </p:sp>
       <p:pic>
         <p:nvPicPr>
-          <p:cNvPr id="20" name=""/>
+          <p:cNvPr id="22" name=""/>
           <p:cNvPicPr>
             <a:picLocks xmlns:a="http://schemas.openxmlformats.org/drawingml/2006/main" noChangeAspect="1"/>
           </p:cNvPicPr>
           <p:nvPr/>
         </p:nvPicPr>
         <p:blipFill>
-          <a:blip xmlns:r="http://schemas.openxmlformats.org/officeDocument/2006/relationships" xmlns:a="http://schemas.openxmlformats.org/drawingml/2006/main" r:embed="R2caf6fc97860496d"/>
+          <a:blip xmlns:r="http://schemas.openxmlformats.org/officeDocument/2006/relationships" xmlns:a="http://schemas.openxmlformats.org/drawingml/2006/main" r:embed="Re09aa9e4fcbb4a48"/>
           <a:stretch xmlns:a="http://schemas.openxmlformats.org/drawingml/2006/main"/>
         </p:blipFill>
         <p:spPr>
@@ -6298,10 +6355,10 @@
       </p:pic>
       <p:sp>
         <p:nvSpPr>
-          <p:cNvPr id="10" name="">
+          <p:cNvPr id="11" name="">
             <a:extLst xmlns:a="http://schemas.openxmlformats.org/drawingml/2006/main">
               <a:ext uri="{FF2B5EF4-FFF2-40B4-BE49-F238E27FC236}">
-                <a16:creationId xmlns:a16="http://schemas.microsoft.com/office/drawing/2014/main" id="{81F62DF4-55FE-4DE3-834E-328D9F70B752}"/>
+                <a16:creationId xmlns:a16="http://schemas.microsoft.com/office/drawing/2014/main" id="{61D00252-13B9-47DF-9875-1B87A899343A}"/>
               </a:ext>
             </a:extLst>
           </p:cNvPr>
@@ -6355,10 +6412,10 @@
       </p:sp>
       <p:sp>
         <p:nvSpPr>
-          <p:cNvPr id="11" name="">
+          <p:cNvPr id="12" name="">
             <a:extLst xmlns:a="http://schemas.openxmlformats.org/drawingml/2006/main">
               <a:ext uri="{FF2B5EF4-FFF2-40B4-BE49-F238E27FC236}">
-                <a16:creationId xmlns:a16="http://schemas.microsoft.com/office/drawing/2014/main" id="{45E6FCAA-8FA9-4139-B558-09F58C81AA8D}"/>
+                <a16:creationId xmlns:a16="http://schemas.microsoft.com/office/drawing/2014/main" id="{77C6A4A1-5478-4FE7-906B-B61C8C64DB6E}"/>
               </a:ext>
             </a:extLst>
           </p:cNvPr>
@@ -6413,7 +6470,7 @@
     </p:spTree>
     <p:extLst>
       <p:ext uri="{BB962C8B-B14F-4D97-AF65-F5344CB8AC3E}">
-        <p14:creationId xmlns:p14="http://schemas.microsoft.com/office/powerpoint/2010/main" val="423088871"/>
+        <p14:creationId xmlns:p14="http://schemas.microsoft.com/office/powerpoint/2010/main" val="633032130"/>
       </p:ext>
     </p:extLst>
   </p:cSld>
@@ -6444,7 +6501,7 @@
           <p:cNvPr id="6" name="">
             <a:extLst xmlns:a="http://schemas.openxmlformats.org/drawingml/2006/main">
               <a:ext uri="{FF2B5EF4-FFF2-40B4-BE49-F238E27FC236}">
-                <a16:creationId xmlns:a16="http://schemas.microsoft.com/office/drawing/2014/main" id="{CC17F88F-0C50-481F-8F4A-39382648C72F}"/>
+                <a16:creationId xmlns:a16="http://schemas.microsoft.com/office/drawing/2014/main" id="{94FCCB5A-EF69-490D-8AC2-B92E8BC7FEEA}"/>
               </a:ext>
             </a:extLst>
           </p:cNvPr>
@@ -6501,7 +6558,7 @@
           <p:cNvPr id="2" name="">
             <a:extLst xmlns:a="http://schemas.openxmlformats.org/drawingml/2006/main">
               <a:ext uri="{FF2B5EF4-FFF2-40B4-BE49-F238E27FC236}">
-                <a16:creationId xmlns:a16="http://schemas.microsoft.com/office/drawing/2014/main" id="{F936730E-A1B1-48CA-B171-E63FD15891AD}"/>
+                <a16:creationId xmlns:a16="http://schemas.microsoft.com/office/drawing/2014/main" id="{1572480F-F508-49D5-A46B-9310A954DAB1}"/>
               </a:ext>
             </a:extLst>
           </p:cNvPr>
@@ -6558,7 +6615,7 @@
           <p:cNvPr id="3" name="">
             <a:extLst xmlns:a="http://schemas.openxmlformats.org/drawingml/2006/main">
               <a:ext uri="{FF2B5EF4-FFF2-40B4-BE49-F238E27FC236}">
-                <a16:creationId xmlns:a16="http://schemas.microsoft.com/office/drawing/2014/main" id="{605D8F6B-358C-4204-90AB-1EB8D7EAE0C7}"/>
+                <a16:creationId xmlns:a16="http://schemas.microsoft.com/office/drawing/2014/main" id="{D3CBC248-6406-48AF-BF98-17D493B80EF8}"/>
               </a:ext>
             </a:extLst>
           </p:cNvPr>
@@ -7982,7 +8039,7 @@
           <p:cNvPr id="5" name="">
             <a:extLst xmlns:a="http://schemas.openxmlformats.org/drawingml/2006/main">
               <a:ext uri="{FF2B5EF4-FFF2-40B4-BE49-F238E27FC236}">
-                <a16:creationId xmlns:a16="http://schemas.microsoft.com/office/drawing/2014/main" id="{F94A898A-138B-4F19-BF19-25CBB49086B6}"/>
+                <a16:creationId xmlns:a16="http://schemas.microsoft.com/office/drawing/2014/main" id="{9E6E5064-B6E4-4139-9502-8B1982F9F1A6}"/>
               </a:ext>
             </a:extLst>
           </p:cNvPr>
@@ -8060,7 +8117,7 @@
     </p:spTree>
     <p:extLst>
       <p:ext uri="{BB962C8B-B14F-4D97-AF65-F5344CB8AC3E}">
-        <p14:creationId xmlns:p14="http://schemas.microsoft.com/office/powerpoint/2010/main" val="468173533"/>
+        <p14:creationId xmlns:p14="http://schemas.microsoft.com/office/powerpoint/2010/main" val="415127506"/>
       </p:ext>
     </p:extLst>
   </p:cSld>
@@ -8091,7 +8148,7 @@
           <p:cNvPr id="8" name="">
             <a:extLst xmlns:a="http://schemas.openxmlformats.org/drawingml/2006/main">
               <a:ext uri="{FF2B5EF4-FFF2-40B4-BE49-F238E27FC236}">
-                <a16:creationId xmlns:a16="http://schemas.microsoft.com/office/drawing/2014/main" id="{0F44F672-0BC0-4511-89D2-62AA6C9FD19F}"/>
+                <a16:creationId xmlns:a16="http://schemas.microsoft.com/office/drawing/2014/main" id="{4A4DC368-BE63-47B8-BBD8-9DA278FEE1C4}"/>
               </a:ext>
             </a:extLst>
           </p:cNvPr>
@@ -8148,7 +8205,7 @@
           <p:cNvPr id="2" name="">
             <a:extLst xmlns:a="http://schemas.openxmlformats.org/drawingml/2006/main">
               <a:ext uri="{FF2B5EF4-FFF2-40B4-BE49-F238E27FC236}">
-                <a16:creationId xmlns:a16="http://schemas.microsoft.com/office/drawing/2014/main" id="{32D4F2D1-B9C4-4CAA-B25F-D127D42D0A98}"/>
+                <a16:creationId xmlns:a16="http://schemas.microsoft.com/office/drawing/2014/main" id="{4F3F17FC-0B82-4F80-8E57-2A0C17DD6CA2}"/>
               </a:ext>
             </a:extLst>
           </p:cNvPr>
@@ -8205,7 +8262,7 @@
           <p:cNvPr id="3" name="">
             <a:extLst xmlns:a="http://schemas.openxmlformats.org/drawingml/2006/main">
               <a:ext uri="{FF2B5EF4-FFF2-40B4-BE49-F238E27FC236}">
-                <a16:creationId xmlns:a16="http://schemas.microsoft.com/office/drawing/2014/main" id="{E4C59730-0F36-4127-AD0E-B662C4349F70}"/>
+                <a16:creationId xmlns:a16="http://schemas.microsoft.com/office/drawing/2014/main" id="{94ACAE73-1C23-47A8-BF72-B2C77D8E8FE2}"/>
               </a:ext>
             </a:extLst>
           </p:cNvPr>
@@ -8262,7 +8319,7 @@
           <p:cNvPr id="4" name="">
             <a:extLst xmlns:a="http://schemas.openxmlformats.org/drawingml/2006/main">
               <a:ext uri="{FF2B5EF4-FFF2-40B4-BE49-F238E27FC236}">
-                <a16:creationId xmlns:a16="http://schemas.microsoft.com/office/drawing/2014/main" id="{E818C236-D4BD-46B8-AA68-0E09DD798FA6}"/>
+                <a16:creationId xmlns:a16="http://schemas.microsoft.com/office/drawing/2014/main" id="{6B329667-9CB8-4AA2-BA8B-5F3D8CAE4E1F}"/>
               </a:ext>
             </a:extLst>
           </p:cNvPr>
@@ -8319,7 +8376,7 @@
           <p:cNvPr id="5" name="">
             <a:extLst xmlns:a="http://schemas.openxmlformats.org/drawingml/2006/main">
               <a:ext uri="{FF2B5EF4-FFF2-40B4-BE49-F238E27FC236}">
-                <a16:creationId xmlns:a16="http://schemas.microsoft.com/office/drawing/2014/main" id="{DF236B98-315B-4E11-BB46-EA9317BAE068}"/>
+                <a16:creationId xmlns:a16="http://schemas.microsoft.com/office/drawing/2014/main" id="{67E25411-E948-4239-9A68-CE6284F3ED98}"/>
               </a:ext>
             </a:extLst>
           </p:cNvPr>
@@ -8483,7 +8540,7 @@
           <p:cNvPr id="6" name="">
             <a:extLst xmlns:a="http://schemas.openxmlformats.org/drawingml/2006/main">
               <a:ext uri="{FF2B5EF4-FFF2-40B4-BE49-F238E27FC236}">
-                <a16:creationId xmlns:a16="http://schemas.microsoft.com/office/drawing/2014/main" id="{A12583D1-B50A-4810-981C-8DDD225C2F05}"/>
+                <a16:creationId xmlns:a16="http://schemas.microsoft.com/office/drawing/2014/main" id="{93B98B8A-2576-4ECA-B5F0-E803A327282F}"/>
               </a:ext>
             </a:extLst>
           </p:cNvPr>
@@ -8540,7 +8597,7 @@
           <p:cNvPr id="7" name="">
             <a:extLst xmlns:a="http://schemas.openxmlformats.org/drawingml/2006/main">
               <a:ext uri="{FF2B5EF4-FFF2-40B4-BE49-F238E27FC236}">
-                <a16:creationId xmlns:a16="http://schemas.microsoft.com/office/drawing/2014/main" id="{8340414C-7EEC-4048-A25D-8A7F5F0A7C02}"/>
+                <a16:creationId xmlns:a16="http://schemas.microsoft.com/office/drawing/2014/main" id="{5382C60B-D133-4906-A1AA-CC120C759EE9}"/>
               </a:ext>
             </a:extLst>
           </p:cNvPr>
@@ -8702,7 +8759,7 @@
     </p:spTree>
     <p:extLst>
       <p:ext uri="{BB962C8B-B14F-4D97-AF65-F5344CB8AC3E}">
-        <p14:creationId xmlns:p14="http://schemas.microsoft.com/office/powerpoint/2010/main" val="420725632"/>
+        <p14:creationId xmlns:p14="http://schemas.microsoft.com/office/powerpoint/2010/main" val="796232433"/>
       </p:ext>
     </p:extLst>
   </p:cSld>
@@ -8733,7 +8790,7 @@
           <p:cNvPr id="16" name="">
             <a:extLst xmlns:a="http://schemas.openxmlformats.org/drawingml/2006/main">
               <a:ext uri="{FF2B5EF4-FFF2-40B4-BE49-F238E27FC236}">
-                <a16:creationId xmlns:a16="http://schemas.microsoft.com/office/drawing/2014/main" id="{D0F35E62-B833-4321-AE78-ABC144C103AA}"/>
+                <a16:creationId xmlns:a16="http://schemas.microsoft.com/office/drawing/2014/main" id="{5AA9C3A1-E183-468F-B4EE-0AEBC2A58C67}"/>
               </a:ext>
             </a:extLst>
           </p:cNvPr>
@@ -8790,7 +8847,7 @@
           <p:cNvPr id="2" name="">
             <a:extLst xmlns:a="http://schemas.openxmlformats.org/drawingml/2006/main">
               <a:ext uri="{FF2B5EF4-FFF2-40B4-BE49-F238E27FC236}">
-                <a16:creationId xmlns:a16="http://schemas.microsoft.com/office/drawing/2014/main" id="{112FA9C3-8EC9-41A7-8569-58661E42B2FC}"/>
+                <a16:creationId xmlns:a16="http://schemas.microsoft.com/office/drawing/2014/main" id="{73C47CAF-5221-42F3-9CF5-7155FAC1BCE7}"/>
               </a:ext>
             </a:extLst>
           </p:cNvPr>
@@ -8847,7 +8904,7 @@
           <p:cNvPr id="3" name="">
             <a:extLst xmlns:a="http://schemas.openxmlformats.org/drawingml/2006/main">
               <a:ext uri="{FF2B5EF4-FFF2-40B4-BE49-F238E27FC236}">
-                <a16:creationId xmlns:a16="http://schemas.microsoft.com/office/drawing/2014/main" id="{6D671369-DF27-45C7-8F9E-038E377FD754}"/>
+                <a16:creationId xmlns:a16="http://schemas.microsoft.com/office/drawing/2014/main" id="{DD051AF4-AE03-4950-B1FD-FADA1AE54875}"/>
               </a:ext>
             </a:extLst>
           </p:cNvPr>
@@ -8904,7 +8961,7 @@
           <p:cNvPr id="4" name="">
             <a:extLst xmlns:a="http://schemas.openxmlformats.org/drawingml/2006/main">
               <a:ext uri="{FF2B5EF4-FFF2-40B4-BE49-F238E27FC236}">
-                <a16:creationId xmlns:a16="http://schemas.microsoft.com/office/drawing/2014/main" id="{FC5A8028-D58B-4280-9334-B141925E1CC0}"/>
+                <a16:creationId xmlns:a16="http://schemas.microsoft.com/office/drawing/2014/main" id="{50C13B8E-964F-4A20-9F05-653BEB47BC52}"/>
               </a:ext>
             </a:extLst>
           </p:cNvPr>
@@ -8961,7 +9018,7 @@
           <p:cNvPr id="5" name="">
             <a:extLst xmlns:a="http://schemas.openxmlformats.org/drawingml/2006/main">
               <a:ext uri="{FF2B5EF4-FFF2-40B4-BE49-F238E27FC236}">
-                <a16:creationId xmlns:a16="http://schemas.microsoft.com/office/drawing/2014/main" id="{CEBFB54C-C0B5-4507-A2CE-0D728EF62013}"/>
+                <a16:creationId xmlns:a16="http://schemas.microsoft.com/office/drawing/2014/main" id="{04848CDC-F089-4D0D-985E-2089E9190843}"/>
               </a:ext>
             </a:extLst>
           </p:cNvPr>
@@ -9025,7 +9082,7 @@
         </p:xfrm>
         <a:graphic xmlns:a="http://schemas.openxmlformats.org/drawingml/2006/main">
           <a:graphicData uri="http://schemas.openxmlformats.org/drawingml/2006/chart">
-            <c:chart xmlns:r="http://schemas.openxmlformats.org/officeDocument/2006/relationships" xmlns:c="http://schemas.openxmlformats.org/drawingml/2006/chart" r:id="R314967f50148430d"/>
+            <c:chart xmlns:r="http://schemas.openxmlformats.org/officeDocument/2006/relationships" xmlns:c="http://schemas.openxmlformats.org/drawingml/2006/chart" r:id="Rd765b13eea1347b7"/>
           </a:graphicData>
         </a:graphic>
       </p:graphicFrame>
@@ -9034,7 +9091,7 @@
           <p:cNvPr id="7" name="">
             <a:extLst xmlns:a="http://schemas.openxmlformats.org/drawingml/2006/main">
               <a:ext uri="{FF2B5EF4-FFF2-40B4-BE49-F238E27FC236}">
-                <a16:creationId xmlns:a16="http://schemas.microsoft.com/office/drawing/2014/main" id="{F4F649ED-20F2-4CD1-A661-629DB0256364}"/>
+                <a16:creationId xmlns:a16="http://schemas.microsoft.com/office/drawing/2014/main" id="{D4DC52FD-3FB8-4283-8293-7642700FD122}"/>
               </a:ext>
             </a:extLst>
           </p:cNvPr>
@@ -9091,7 +9148,7 @@
           <p:cNvPr id="8" name="">
             <a:extLst xmlns:a="http://schemas.openxmlformats.org/drawingml/2006/main">
               <a:ext uri="{FF2B5EF4-FFF2-40B4-BE49-F238E27FC236}">
-                <a16:creationId xmlns:a16="http://schemas.microsoft.com/office/drawing/2014/main" id="{70A9F71C-83CC-4333-8CF3-F4BDAA092758}"/>
+                <a16:creationId xmlns:a16="http://schemas.microsoft.com/office/drawing/2014/main" id="{63E7FEE9-D953-4D11-83AF-819250237195}"/>
               </a:ext>
             </a:extLst>
           </p:cNvPr>
@@ -9155,7 +9212,7 @@
         </p:xfrm>
         <a:graphic xmlns:a="http://schemas.openxmlformats.org/drawingml/2006/main">
           <a:graphicData uri="http://schemas.openxmlformats.org/drawingml/2006/chart">
-            <c:chart xmlns:r="http://schemas.openxmlformats.org/officeDocument/2006/relationships" xmlns:c="http://schemas.openxmlformats.org/drawingml/2006/chart" r:id="R7c8b7646f8344f30"/>
+            <c:chart xmlns:r="http://schemas.openxmlformats.org/officeDocument/2006/relationships" xmlns:c="http://schemas.openxmlformats.org/drawingml/2006/chart" r:id="R059fbba1b00642a2"/>
           </a:graphicData>
         </a:graphic>
       </p:graphicFrame>
@@ -9164,7 +9221,7 @@
           <p:cNvPr id="10" name="">
             <a:extLst xmlns:a="http://schemas.openxmlformats.org/drawingml/2006/main">
               <a:ext uri="{FF2B5EF4-FFF2-40B4-BE49-F238E27FC236}">
-                <a16:creationId xmlns:a16="http://schemas.microsoft.com/office/drawing/2014/main" id="{4F0C7815-1F64-455C-BC12-188AAA05EE14}"/>
+                <a16:creationId xmlns:a16="http://schemas.microsoft.com/office/drawing/2014/main" id="{38B955EB-A69C-49C9-AD92-7D6CEBC03AF5}"/>
               </a:ext>
             </a:extLst>
           </p:cNvPr>
@@ -9221,7 +9278,7 @@
           <p:cNvPr id="11" name="">
             <a:extLst xmlns:a="http://schemas.openxmlformats.org/drawingml/2006/main">
               <a:ext uri="{FF2B5EF4-FFF2-40B4-BE49-F238E27FC236}">
-                <a16:creationId xmlns:a16="http://schemas.microsoft.com/office/drawing/2014/main" id="{54CE2ED1-CAF1-4D6A-84BB-E4BB44CECB48}"/>
+                <a16:creationId xmlns:a16="http://schemas.microsoft.com/office/drawing/2014/main" id="{A837B176-3BA6-4FD9-82BA-95E30FBCA5EA}"/>
               </a:ext>
             </a:extLst>
           </p:cNvPr>
@@ -9285,7 +9342,7 @@
         </p:xfrm>
         <a:graphic xmlns:a="http://schemas.openxmlformats.org/drawingml/2006/main">
           <a:graphicData uri="http://schemas.openxmlformats.org/drawingml/2006/chart">
-            <c:chart xmlns:r="http://schemas.openxmlformats.org/officeDocument/2006/relationships" xmlns:c="http://schemas.openxmlformats.org/drawingml/2006/chart" r:id="Re028683c8ac14231"/>
+            <c:chart xmlns:r="http://schemas.openxmlformats.org/officeDocument/2006/relationships" xmlns:c="http://schemas.openxmlformats.org/drawingml/2006/chart" r:id="Rfff43c597ec04674"/>
           </a:graphicData>
         </a:graphic>
       </p:graphicFrame>
@@ -9294,7 +9351,7 @@
           <p:cNvPr id="13" name="">
             <a:extLst xmlns:a="http://schemas.openxmlformats.org/drawingml/2006/main">
               <a:ext uri="{FF2B5EF4-FFF2-40B4-BE49-F238E27FC236}">
-                <a16:creationId xmlns:a16="http://schemas.microsoft.com/office/drawing/2014/main" id="{5846937D-9F72-489B-AE57-6BAA713B0589}"/>
+                <a16:creationId xmlns:a16="http://schemas.microsoft.com/office/drawing/2014/main" id="{68082F84-A409-41E6-AACA-849F81C861BB}"/>
               </a:ext>
             </a:extLst>
           </p:cNvPr>
@@ -9324,7 +9381,7 @@
           <p:cNvPr id="14" name="">
             <a:extLst xmlns:a="http://schemas.openxmlformats.org/drawingml/2006/main">
               <a:ext uri="{FF2B5EF4-FFF2-40B4-BE49-F238E27FC236}">
-                <a16:creationId xmlns:a16="http://schemas.microsoft.com/office/drawing/2014/main" id="{52268BF4-39A1-412F-9745-AEEAEEA3107C}"/>
+                <a16:creationId xmlns:a16="http://schemas.microsoft.com/office/drawing/2014/main" id="{AB38786C-F92E-4D9A-832A-F572308F3DC9}"/>
               </a:ext>
             </a:extLst>
           </p:cNvPr>
@@ -9381,7 +9438,7 @@
           <p:cNvPr id="15" name="">
             <a:extLst xmlns:a="http://schemas.openxmlformats.org/drawingml/2006/main">
               <a:ext uri="{FF2B5EF4-FFF2-40B4-BE49-F238E27FC236}">
-                <a16:creationId xmlns:a16="http://schemas.microsoft.com/office/drawing/2014/main" id="{32CDC249-02B6-44B5-9B8E-3B8450FFCF34}"/>
+                <a16:creationId xmlns:a16="http://schemas.microsoft.com/office/drawing/2014/main" id="{15479A89-681B-46AB-A914-685DC6AF4303}"/>
               </a:ext>
             </a:extLst>
           </p:cNvPr>
@@ -9436,7 +9493,7 @@
     </p:spTree>
     <p:extLst>
       <p:ext uri="{BB962C8B-B14F-4D97-AF65-F5344CB8AC3E}">
-        <p14:creationId xmlns:p14="http://schemas.microsoft.com/office/powerpoint/2010/main" val="653710919"/>
+        <p14:creationId xmlns:p14="http://schemas.microsoft.com/office/powerpoint/2010/main" val="1145470438"/>
       </p:ext>
     </p:extLst>
   </p:cSld>
@@ -9467,7 +9524,7 @@
           <p:cNvPr id="8" name="">
             <a:extLst xmlns:a="http://schemas.openxmlformats.org/drawingml/2006/main">
               <a:ext uri="{FF2B5EF4-FFF2-40B4-BE49-F238E27FC236}">
-                <a16:creationId xmlns:a16="http://schemas.microsoft.com/office/drawing/2014/main" id="{CBC2E274-A030-4AF4-A8F5-92630DDD7C14}"/>
+                <a16:creationId xmlns:a16="http://schemas.microsoft.com/office/drawing/2014/main" id="{6D1D6734-D56E-42A7-BDE8-BFBEF8EEA7EE}"/>
               </a:ext>
             </a:extLst>
           </p:cNvPr>
@@ -9524,7 +9581,7 @@
           <p:cNvPr id="2" name="">
             <a:extLst xmlns:a="http://schemas.openxmlformats.org/drawingml/2006/main">
               <a:ext uri="{FF2B5EF4-FFF2-40B4-BE49-F238E27FC236}">
-                <a16:creationId xmlns:a16="http://schemas.microsoft.com/office/drawing/2014/main" id="{7391AF1C-9402-4A82-93D9-D43F03850039}"/>
+                <a16:creationId xmlns:a16="http://schemas.microsoft.com/office/drawing/2014/main" id="{A9FBE38C-E431-4144-BE63-8FB5C78D5008}"/>
               </a:ext>
             </a:extLst>
           </p:cNvPr>
@@ -9581,7 +9638,7 @@
           <p:cNvPr id="3" name="">
             <a:extLst xmlns:a="http://schemas.openxmlformats.org/drawingml/2006/main">
               <a:ext uri="{FF2B5EF4-FFF2-40B4-BE49-F238E27FC236}">
-                <a16:creationId xmlns:a16="http://schemas.microsoft.com/office/drawing/2014/main" id="{E2D598AF-3A20-4346-8178-F31D9CCDF8E4}"/>
+                <a16:creationId xmlns:a16="http://schemas.microsoft.com/office/drawing/2014/main" id="{876BEC77-A028-46AF-9948-B221BF29974D}"/>
               </a:ext>
             </a:extLst>
           </p:cNvPr>
@@ -9645,7 +9702,7 @@
         </p:xfrm>
         <a:graphic xmlns:a="http://schemas.openxmlformats.org/drawingml/2006/main">
           <a:graphicData uri="http://schemas.openxmlformats.org/drawingml/2006/chart">
-            <c:chart xmlns:r="http://schemas.openxmlformats.org/officeDocument/2006/relationships" xmlns:c="http://schemas.openxmlformats.org/drawingml/2006/chart" r:id="R29dd2b272e194129"/>
+            <c:chart xmlns:r="http://schemas.openxmlformats.org/officeDocument/2006/relationships" xmlns:c="http://schemas.openxmlformats.org/drawingml/2006/chart" r:id="R2bbd0ad31a6c4053"/>
           </a:graphicData>
         </a:graphic>
       </p:graphicFrame>
@@ -10560,7 +10617,7 @@
           <p:cNvPr id="6" name="">
             <a:extLst xmlns:a="http://schemas.openxmlformats.org/drawingml/2006/main">
               <a:ext uri="{FF2B5EF4-FFF2-40B4-BE49-F238E27FC236}">
-                <a16:creationId xmlns:a16="http://schemas.microsoft.com/office/drawing/2014/main" id="{EFC18465-8519-4FE5-924F-7332EE646C1F}"/>
+                <a16:creationId xmlns:a16="http://schemas.microsoft.com/office/drawing/2014/main" id="{6F7D29C6-894C-421A-B729-088A99CF97FA}"/>
               </a:ext>
             </a:extLst>
           </p:cNvPr>
@@ -10617,7 +10674,7 @@
           <p:cNvPr id="7" name="">
             <a:extLst xmlns:a="http://schemas.openxmlformats.org/drawingml/2006/main">
               <a:ext uri="{FF2B5EF4-FFF2-40B4-BE49-F238E27FC236}">
-                <a16:creationId xmlns:a16="http://schemas.microsoft.com/office/drawing/2014/main" id="{6F1D9C5E-E513-4A71-AE86-8A2534A867F1}"/>
+                <a16:creationId xmlns:a16="http://schemas.microsoft.com/office/drawing/2014/main" id="{4763CE60-59C8-4DEF-87CC-1D07B5D22F8B}"/>
               </a:ext>
             </a:extLst>
           </p:cNvPr>
@@ -10695,7 +10752,7 @@
     </p:spTree>
     <p:extLst>
       <p:ext uri="{BB962C8B-B14F-4D97-AF65-F5344CB8AC3E}">
-        <p14:creationId xmlns:p14="http://schemas.microsoft.com/office/powerpoint/2010/main" val="1030765572"/>
+        <p14:creationId xmlns:p14="http://schemas.microsoft.com/office/powerpoint/2010/main" val="909954745"/>
       </p:ext>
     </p:extLst>
   </p:cSld>
@@ -10726,7 +10783,7 @@
           <p:cNvPr id="7" name="">
             <a:extLst xmlns:a="http://schemas.openxmlformats.org/drawingml/2006/main">
               <a:ext uri="{FF2B5EF4-FFF2-40B4-BE49-F238E27FC236}">
-                <a16:creationId xmlns:a16="http://schemas.microsoft.com/office/drawing/2014/main" id="{D2CB547E-BD97-4CFC-BEB8-A85F5D7A0F05}"/>
+                <a16:creationId xmlns:a16="http://schemas.microsoft.com/office/drawing/2014/main" id="{FC027099-D5F1-4705-9F14-563DFDF285A5}"/>
               </a:ext>
             </a:extLst>
           </p:cNvPr>
@@ -10783,7 +10840,7 @@
           <p:cNvPr id="2" name="">
             <a:extLst xmlns:a="http://schemas.openxmlformats.org/drawingml/2006/main">
               <a:ext uri="{FF2B5EF4-FFF2-40B4-BE49-F238E27FC236}">
-                <a16:creationId xmlns:a16="http://schemas.microsoft.com/office/drawing/2014/main" id="{CBCA2758-905B-4BEB-8EC1-70F69F3C86C6}"/>
+                <a16:creationId xmlns:a16="http://schemas.microsoft.com/office/drawing/2014/main" id="{74A8830E-4EDF-4D50-9B0B-4517490A72AC}"/>
               </a:ext>
             </a:extLst>
           </p:cNvPr>
@@ -10840,7 +10897,7 @@
           <p:cNvPr id="3" name="">
             <a:extLst xmlns:a="http://schemas.openxmlformats.org/drawingml/2006/main">
               <a:ext uri="{FF2B5EF4-FFF2-40B4-BE49-F238E27FC236}">
-                <a16:creationId xmlns:a16="http://schemas.microsoft.com/office/drawing/2014/main" id="{3827D382-9009-46BB-9797-BF169998723E}"/>
+                <a16:creationId xmlns:a16="http://schemas.microsoft.com/office/drawing/2014/main" id="{C5559E2F-958B-4C3F-8E9E-58C4C51BCF51}"/>
               </a:ext>
             </a:extLst>
           </p:cNvPr>
@@ -10901,7 +10958,7 @@
           <p:nvPr/>
         </p:nvPicPr>
         <p:blipFill>
-          <a:blip xmlns:r="http://schemas.openxmlformats.org/officeDocument/2006/relationships" xmlns:a="http://schemas.openxmlformats.org/drawingml/2006/main" r:embed="R72e9089b437e4e9c"/>
+          <a:blip xmlns:r="http://schemas.openxmlformats.org/officeDocument/2006/relationships" xmlns:a="http://schemas.openxmlformats.org/drawingml/2006/main" r:embed="R7054a5eb35514b35"/>
           <a:stretch xmlns:a="http://schemas.openxmlformats.org/drawingml/2006/main"/>
         </p:blipFill>
         <p:spPr>
@@ -10919,7 +10976,7 @@
           <p:cNvPr id="5" name="">
             <a:extLst xmlns:a="http://schemas.openxmlformats.org/drawingml/2006/main">
               <a:ext uri="{FF2B5EF4-FFF2-40B4-BE49-F238E27FC236}">
-                <a16:creationId xmlns:a16="http://schemas.microsoft.com/office/drawing/2014/main" id="{D0D02F92-EC33-4CEF-A951-01DBB51E3151}"/>
+                <a16:creationId xmlns:a16="http://schemas.microsoft.com/office/drawing/2014/main" id="{3FFE89FC-A9AB-458B-967D-7F1F2116CB02}"/>
               </a:ext>
             </a:extLst>
           </p:cNvPr>
@@ -11315,7 +11372,7 @@
     </p:spTree>
     <p:extLst>
       <p:ext uri="{BB962C8B-B14F-4D97-AF65-F5344CB8AC3E}">
-        <p14:creationId xmlns:p14="http://schemas.microsoft.com/office/powerpoint/2010/main" val="345825310"/>
+        <p14:creationId xmlns:p14="http://schemas.microsoft.com/office/powerpoint/2010/main" val="294535111"/>
       </p:ext>
     </p:extLst>
   </p:cSld>
@@ -11346,7 +11403,7 @@
           <p:cNvPr id="6" name="">
             <a:extLst xmlns:a="http://schemas.openxmlformats.org/drawingml/2006/main">
               <a:ext uri="{FF2B5EF4-FFF2-40B4-BE49-F238E27FC236}">
-                <a16:creationId xmlns:a16="http://schemas.microsoft.com/office/drawing/2014/main" id="{39A80459-A078-4B38-8656-382071D04A7B}"/>
+                <a16:creationId xmlns:a16="http://schemas.microsoft.com/office/drawing/2014/main" id="{DACFE8A6-7DAC-43B4-B51F-79365C051628}"/>
               </a:ext>
             </a:extLst>
           </p:cNvPr>
@@ -11403,7 +11460,7 @@
           <p:cNvPr id="2" name="">
             <a:extLst xmlns:a="http://schemas.openxmlformats.org/drawingml/2006/main">
               <a:ext uri="{FF2B5EF4-FFF2-40B4-BE49-F238E27FC236}">
-                <a16:creationId xmlns:a16="http://schemas.microsoft.com/office/drawing/2014/main" id="{F75D930F-F7EA-46DC-B213-010DE913D231}"/>
+                <a16:creationId xmlns:a16="http://schemas.microsoft.com/office/drawing/2014/main" id="{3204FF16-0D1E-4CC8-A8AC-9BD7F099A111}"/>
               </a:ext>
             </a:extLst>
           </p:cNvPr>
@@ -11460,7 +11517,7 @@
           <p:cNvPr id="3" name="">
             <a:extLst xmlns:a="http://schemas.openxmlformats.org/drawingml/2006/main">
               <a:ext uri="{FF2B5EF4-FFF2-40B4-BE49-F238E27FC236}">
-                <a16:creationId xmlns:a16="http://schemas.microsoft.com/office/drawing/2014/main" id="{B48F074B-EC8E-4FAF-8779-E02C05373F0B}"/>
+                <a16:creationId xmlns:a16="http://schemas.microsoft.com/office/drawing/2014/main" id="{1CE7838D-CD56-467E-A1C9-56ADD9C03C15}"/>
               </a:ext>
             </a:extLst>
           </p:cNvPr>
@@ -11524,7 +11581,7 @@
         </p:xfrm>
         <a:graphic xmlns:a="http://schemas.openxmlformats.org/drawingml/2006/main">
           <a:graphicData uri="http://schemas.openxmlformats.org/drawingml/2006/chart">
-            <c:chart xmlns:r="http://schemas.openxmlformats.org/officeDocument/2006/relationships" xmlns:c="http://schemas.openxmlformats.org/drawingml/2006/chart" r:id="Ra086b668a28e4ddc"/>
+            <c:chart xmlns:r="http://schemas.openxmlformats.org/officeDocument/2006/relationships" xmlns:c="http://schemas.openxmlformats.org/drawingml/2006/chart" r:id="Rcf8c9088f89b4150"/>
           </a:graphicData>
         </a:graphic>
       </p:graphicFrame>
@@ -11533,7 +11590,7 @@
           <p:cNvPr id="5" name="">
             <a:extLst xmlns:a="http://schemas.openxmlformats.org/drawingml/2006/main">
               <a:ext uri="{FF2B5EF4-FFF2-40B4-BE49-F238E27FC236}">
-                <a16:creationId xmlns:a16="http://schemas.microsoft.com/office/drawing/2014/main" id="{C22B09C1-CAD3-4EC2-B643-1BE3F683EF9E}"/>
+                <a16:creationId xmlns:a16="http://schemas.microsoft.com/office/drawing/2014/main" id="{DE2662F5-2B9C-4899-95B0-83AE36D7C5DE}"/>
               </a:ext>
             </a:extLst>
           </p:cNvPr>
@@ -11611,7 +11668,7 @@
     </p:spTree>
     <p:extLst>
       <p:ext uri="{BB962C8B-B14F-4D97-AF65-F5344CB8AC3E}">
-        <p14:creationId xmlns:p14="http://schemas.microsoft.com/office/powerpoint/2010/main" val="60407636"/>
+        <p14:creationId xmlns:p14="http://schemas.microsoft.com/office/powerpoint/2010/main" val="1344386286"/>
       </p:ext>
     </p:extLst>
   </p:cSld>
@@ -11642,7 +11699,7 @@
           <p:cNvPr id="20" name="">
             <a:extLst xmlns:a="http://schemas.openxmlformats.org/drawingml/2006/main">
               <a:ext uri="{FF2B5EF4-FFF2-40B4-BE49-F238E27FC236}">
-                <a16:creationId xmlns:a16="http://schemas.microsoft.com/office/drawing/2014/main" id="{8655E1CA-E3A3-4328-848B-01E147220C52}"/>
+                <a16:creationId xmlns:a16="http://schemas.microsoft.com/office/drawing/2014/main" id="{88C289AD-64B3-437E-BD52-50F1696E7112}"/>
               </a:ext>
             </a:extLst>
           </p:cNvPr>
@@ -11699,7 +11756,7 @@
           <p:cNvPr id="2" name="">
             <a:extLst xmlns:a="http://schemas.openxmlformats.org/drawingml/2006/main">
               <a:ext uri="{FF2B5EF4-FFF2-40B4-BE49-F238E27FC236}">
-                <a16:creationId xmlns:a16="http://schemas.microsoft.com/office/drawing/2014/main" id="{08B9406D-327E-4455-917A-E12405B2C6B4}"/>
+                <a16:creationId xmlns:a16="http://schemas.microsoft.com/office/drawing/2014/main" id="{6C7372E2-0360-43CF-986B-3FC729D9859B}"/>
               </a:ext>
             </a:extLst>
           </p:cNvPr>
@@ -11756,7 +11813,7 @@
           <p:cNvPr id="3" name="">
             <a:extLst xmlns:a="http://schemas.openxmlformats.org/drawingml/2006/main">
               <a:ext uri="{FF2B5EF4-FFF2-40B4-BE49-F238E27FC236}">
-                <a16:creationId xmlns:a16="http://schemas.microsoft.com/office/drawing/2014/main" id="{25A07B72-DF5F-4B7E-A559-CD60FFA1E82C}"/>
+                <a16:creationId xmlns:a16="http://schemas.microsoft.com/office/drawing/2014/main" id="{94E8356C-C829-4F06-9E69-6F781302144D}"/>
               </a:ext>
             </a:extLst>
           </p:cNvPr>
@@ -11813,7 +11870,7 @@
           <p:cNvPr id="4" name="">
             <a:extLst xmlns:a="http://schemas.openxmlformats.org/drawingml/2006/main">
               <a:ext uri="{FF2B5EF4-FFF2-40B4-BE49-F238E27FC236}">
-                <a16:creationId xmlns:a16="http://schemas.microsoft.com/office/drawing/2014/main" id="{BA1D0940-5357-4CCA-98BB-A789A464FD76}"/>
+                <a16:creationId xmlns:a16="http://schemas.microsoft.com/office/drawing/2014/main" id="{18696258-4E11-4B8D-87AE-B2E84B6E3D40}"/>
               </a:ext>
             </a:extLst>
           </p:cNvPr>
@@ -11897,7 +11954,7 @@
           <p:cNvPr id="5" name="">
             <a:extLst xmlns:a="http://schemas.openxmlformats.org/drawingml/2006/main">
               <a:ext uri="{FF2B5EF4-FFF2-40B4-BE49-F238E27FC236}">
-                <a16:creationId xmlns:a16="http://schemas.microsoft.com/office/drawing/2014/main" id="{C1234AD8-86F0-4800-9959-18DE63F04188}"/>
+                <a16:creationId xmlns:a16="http://schemas.microsoft.com/office/drawing/2014/main" id="{3E4A2DAB-843A-41E2-87C3-628693783870}"/>
               </a:ext>
             </a:extLst>
           </p:cNvPr>
@@ -11927,7 +11984,7 @@
           <p:cNvPr id="6" name="">
             <a:extLst xmlns:a="http://schemas.openxmlformats.org/drawingml/2006/main">
               <a:ext uri="{FF2B5EF4-FFF2-40B4-BE49-F238E27FC236}">
-                <a16:creationId xmlns:a16="http://schemas.microsoft.com/office/drawing/2014/main" id="{D437E956-C411-4BFE-AC4F-8DD15FB755B7}"/>
+                <a16:creationId xmlns:a16="http://schemas.microsoft.com/office/drawing/2014/main" id="{9C2914D1-0FC4-4F35-ADB2-86E45D67289A}"/>
               </a:ext>
             </a:extLst>
           </p:cNvPr>
@@ -12011,7 +12068,7 @@
           <p:cNvPr id="7" name="">
             <a:extLst xmlns:a="http://schemas.openxmlformats.org/drawingml/2006/main">
               <a:ext uri="{FF2B5EF4-FFF2-40B4-BE49-F238E27FC236}">
-                <a16:creationId xmlns:a16="http://schemas.microsoft.com/office/drawing/2014/main" id="{88AEB2AA-223F-4955-8990-94ACA0CFED4C}"/>
+                <a16:creationId xmlns:a16="http://schemas.microsoft.com/office/drawing/2014/main" id="{164F7550-F8B1-4543-A3DA-4D4B039FA8B1}"/>
               </a:ext>
             </a:extLst>
           </p:cNvPr>
@@ -12041,7 +12098,7 @@
           <p:cNvPr id="8" name="">
             <a:extLst xmlns:a="http://schemas.openxmlformats.org/drawingml/2006/main">
               <a:ext uri="{FF2B5EF4-FFF2-40B4-BE49-F238E27FC236}">
-                <a16:creationId xmlns:a16="http://schemas.microsoft.com/office/drawing/2014/main" id="{648F3521-07F7-4D07-85F2-8192E66373AF}"/>
+                <a16:creationId xmlns:a16="http://schemas.microsoft.com/office/drawing/2014/main" id="{592918CA-195D-4A4F-A5F3-1876F5A2A812}"/>
               </a:ext>
             </a:extLst>
           </p:cNvPr>
@@ -12125,7 +12182,7 @@
           <p:cNvPr id="9" name="">
             <a:extLst xmlns:a="http://schemas.openxmlformats.org/drawingml/2006/main">
               <a:ext uri="{FF2B5EF4-FFF2-40B4-BE49-F238E27FC236}">
-                <a16:creationId xmlns:a16="http://schemas.microsoft.com/office/drawing/2014/main" id="{E905984E-3ED9-4E86-BB3B-908AC3D83629}"/>
+                <a16:creationId xmlns:a16="http://schemas.microsoft.com/office/drawing/2014/main" id="{A62E803E-1411-4CC4-9342-9A97284D0C12}"/>
               </a:ext>
             </a:extLst>
           </p:cNvPr>
@@ -12155,7 +12212,7 @@
           <p:cNvPr id="10" name="">
             <a:extLst xmlns:a="http://schemas.openxmlformats.org/drawingml/2006/main">
               <a:ext uri="{FF2B5EF4-FFF2-40B4-BE49-F238E27FC236}">
-                <a16:creationId xmlns:a16="http://schemas.microsoft.com/office/drawing/2014/main" id="{32781812-4557-46CF-8149-D5A8C61C0015}"/>
+                <a16:creationId xmlns:a16="http://schemas.microsoft.com/office/drawing/2014/main" id="{687C4E51-12F2-4BB3-A4CD-BE3E3EDA56D9}"/>
               </a:ext>
             </a:extLst>
           </p:cNvPr>
@@ -12239,7 +12296,7 @@
           <p:cNvPr id="11" name="">
             <a:extLst xmlns:a="http://schemas.openxmlformats.org/drawingml/2006/main">
               <a:ext uri="{FF2B5EF4-FFF2-40B4-BE49-F238E27FC236}">
-                <a16:creationId xmlns:a16="http://schemas.microsoft.com/office/drawing/2014/main" id="{22029622-EDB8-4FC4-9981-C888347020AD}"/>
+                <a16:creationId xmlns:a16="http://schemas.microsoft.com/office/drawing/2014/main" id="{AAF50B75-6837-44E9-BC77-ABF421932CB8}"/>
               </a:ext>
             </a:extLst>
           </p:cNvPr>
@@ -12269,7 +12326,7 @@
           <p:cNvPr id="12" name="">
             <a:extLst xmlns:a="http://schemas.openxmlformats.org/drawingml/2006/main">
               <a:ext uri="{FF2B5EF4-FFF2-40B4-BE49-F238E27FC236}">
-                <a16:creationId xmlns:a16="http://schemas.microsoft.com/office/drawing/2014/main" id="{74DBC4A9-F6E9-441D-B62B-C5C884AAFAF3}"/>
+                <a16:creationId xmlns:a16="http://schemas.microsoft.com/office/drawing/2014/main" id="{CEDE6CB9-5915-4252-86B9-BE5A8A41FBEC}"/>
               </a:ext>
             </a:extLst>
           </p:cNvPr>
@@ -12353,7 +12410,7 @@
           <p:cNvPr id="13" name="">
             <a:extLst xmlns:a="http://schemas.openxmlformats.org/drawingml/2006/main">
               <a:ext uri="{FF2B5EF4-FFF2-40B4-BE49-F238E27FC236}">
-                <a16:creationId xmlns:a16="http://schemas.microsoft.com/office/drawing/2014/main" id="{07A1C8E5-E636-41E9-9A2F-5E0BC02E6E12}"/>
+                <a16:creationId xmlns:a16="http://schemas.microsoft.com/office/drawing/2014/main" id="{E90DF939-633B-4FA7-96E2-C36D239FD99B}"/>
               </a:ext>
             </a:extLst>
           </p:cNvPr>
@@ -12410,7 +12467,7 @@
           <p:cNvPr id="14" name="">
             <a:extLst xmlns:a="http://schemas.openxmlformats.org/drawingml/2006/main">
               <a:ext uri="{FF2B5EF4-FFF2-40B4-BE49-F238E27FC236}">
-                <a16:creationId xmlns:a16="http://schemas.microsoft.com/office/drawing/2014/main" id="{5869FF54-E78F-423E-BCF8-BF5FE1C03333}"/>
+                <a16:creationId xmlns:a16="http://schemas.microsoft.com/office/drawing/2014/main" id="{B858EB6E-B870-4591-BF16-96DA593B7073}"/>
               </a:ext>
             </a:extLst>
           </p:cNvPr>
@@ -12467,7 +12524,7 @@
           <p:cNvPr id="15" name="">
             <a:extLst xmlns:a="http://schemas.openxmlformats.org/drawingml/2006/main">
               <a:ext uri="{FF2B5EF4-FFF2-40B4-BE49-F238E27FC236}">
-                <a16:creationId xmlns:a16="http://schemas.microsoft.com/office/drawing/2014/main" id="{5C836B25-A7EE-438B-90B9-9AA0C7341D67}"/>
+                <a16:creationId xmlns:a16="http://schemas.microsoft.com/office/drawing/2014/main" id="{D7A49DA8-53C9-4A6A-B8B1-9D54DDD56ECD}"/>
               </a:ext>
             </a:extLst>
           </p:cNvPr>
@@ -12639,7 +12696,7 @@
           <p:cNvPr id="16" name="">
             <a:extLst xmlns:a="http://schemas.openxmlformats.org/drawingml/2006/main">
               <a:ext uri="{FF2B5EF4-FFF2-40B4-BE49-F238E27FC236}">
-                <a16:creationId xmlns:a16="http://schemas.microsoft.com/office/drawing/2014/main" id="{8D6C9977-E076-42C6-9FAE-1F32D6399022}"/>
+                <a16:creationId xmlns:a16="http://schemas.microsoft.com/office/drawing/2014/main" id="{ADBDB9B8-AB9A-45EF-9F01-4E04E3F9C2AC}"/>
               </a:ext>
             </a:extLst>
           </p:cNvPr>
@@ -12696,7 +12753,7 @@
           <p:cNvPr id="17" name="">
             <a:extLst xmlns:a="http://schemas.openxmlformats.org/drawingml/2006/main">
               <a:ext uri="{FF2B5EF4-FFF2-40B4-BE49-F238E27FC236}">
-                <a16:creationId xmlns:a16="http://schemas.microsoft.com/office/drawing/2014/main" id="{0A0E3D7C-7988-4000-A31E-8BF847BC17CD}"/>
+                <a16:creationId xmlns:a16="http://schemas.microsoft.com/office/drawing/2014/main" id="{0CD5F54A-8754-4E9D-BF88-88674FE67C7D}"/>
               </a:ext>
             </a:extLst>
           </p:cNvPr>
@@ -12845,7 +12902,7 @@
           <p:cNvPr id="18" name="">
             <a:extLst xmlns:a="http://schemas.openxmlformats.org/drawingml/2006/main">
               <a:ext uri="{FF2B5EF4-FFF2-40B4-BE49-F238E27FC236}">
-                <a16:creationId xmlns:a16="http://schemas.microsoft.com/office/drawing/2014/main" id="{3EB5CAAA-FF65-49F6-947C-7DDF2D33A39F}"/>
+                <a16:creationId xmlns:a16="http://schemas.microsoft.com/office/drawing/2014/main" id="{3A5189DA-A04E-4E1A-8379-E160712F7658}"/>
               </a:ext>
             </a:extLst>
           </p:cNvPr>
@@ -12902,7 +12959,7 @@
           <p:cNvPr id="19" name="">
             <a:extLst xmlns:a="http://schemas.openxmlformats.org/drawingml/2006/main">
               <a:ext uri="{FF2B5EF4-FFF2-40B4-BE49-F238E27FC236}">
-                <a16:creationId xmlns:a16="http://schemas.microsoft.com/office/drawing/2014/main" id="{0CC427DE-BA65-47AE-B81F-218A7B11C16C}"/>
+                <a16:creationId xmlns:a16="http://schemas.microsoft.com/office/drawing/2014/main" id="{1BC3CCDE-1085-4A5F-9461-AE72420B4D72}"/>
               </a:ext>
             </a:extLst>
           </p:cNvPr>
@@ -12957,7 +13014,7 @@
     </p:spTree>
     <p:extLst>
       <p:ext uri="{BB962C8B-B14F-4D97-AF65-F5344CB8AC3E}">
-        <p14:creationId xmlns:p14="http://schemas.microsoft.com/office/powerpoint/2010/main" val="1820478969"/>
+        <p14:creationId xmlns:p14="http://schemas.microsoft.com/office/powerpoint/2010/main" val="857740236"/>
       </p:ext>
     </p:extLst>
   </p:cSld>
@@ -12988,7 +13045,7 @@
           <p:cNvPr id="16" name="">
             <a:extLst xmlns:a="http://schemas.openxmlformats.org/drawingml/2006/main">
               <a:ext uri="{FF2B5EF4-FFF2-40B4-BE49-F238E27FC236}">
-                <a16:creationId xmlns:a16="http://schemas.microsoft.com/office/drawing/2014/main" id="{3C7AAAB0-71ED-46C3-A093-FA0A7529395C}"/>
+                <a16:creationId xmlns:a16="http://schemas.microsoft.com/office/drawing/2014/main" id="{5104E808-4BFE-4C0E-BCDA-0FB6EEF93A16}"/>
               </a:ext>
             </a:extLst>
           </p:cNvPr>
@@ -13045,7 +13102,7 @@
           <p:cNvPr id="2" name="">
             <a:extLst xmlns:a="http://schemas.openxmlformats.org/drawingml/2006/main">
               <a:ext uri="{FF2B5EF4-FFF2-40B4-BE49-F238E27FC236}">
-                <a16:creationId xmlns:a16="http://schemas.microsoft.com/office/drawing/2014/main" id="{28C131D7-5778-4B46-8F14-64E5CC89F837}"/>
+                <a16:creationId xmlns:a16="http://schemas.microsoft.com/office/drawing/2014/main" id="{5D795FD6-D504-40F1-A6B0-F0AC9FEDEC3F}"/>
               </a:ext>
             </a:extLst>
           </p:cNvPr>
@@ -13102,7 +13159,7 @@
           <p:cNvPr id="3" name="">
             <a:extLst xmlns:a="http://schemas.openxmlformats.org/drawingml/2006/main">
               <a:ext uri="{FF2B5EF4-FFF2-40B4-BE49-F238E27FC236}">
-                <a16:creationId xmlns:a16="http://schemas.microsoft.com/office/drawing/2014/main" id="{05751847-323E-4776-A7D2-172751ED3BDF}"/>
+                <a16:creationId xmlns:a16="http://schemas.microsoft.com/office/drawing/2014/main" id="{2F8DC1D7-DFB7-414C-9F58-4DC20EBA6E1B}"/>
               </a:ext>
             </a:extLst>
           </p:cNvPr>
@@ -13159,7 +13216,7 @@
           <p:cNvPr id="4" name="">
             <a:extLst xmlns:a="http://schemas.openxmlformats.org/drawingml/2006/main">
               <a:ext uri="{FF2B5EF4-FFF2-40B4-BE49-F238E27FC236}">
-                <a16:creationId xmlns:a16="http://schemas.microsoft.com/office/drawing/2014/main" id="{C03599EF-0216-420E-87B3-287058E7FDEF}"/>
+                <a16:creationId xmlns:a16="http://schemas.microsoft.com/office/drawing/2014/main" id="{8D63EDCC-B9EC-441D-8562-BDC80A239753}"/>
               </a:ext>
             </a:extLst>
           </p:cNvPr>
@@ -13243,7 +13300,7 @@
           <p:cNvPr id="5" name="">
             <a:extLst xmlns:a="http://schemas.openxmlformats.org/drawingml/2006/main">
               <a:ext uri="{FF2B5EF4-FFF2-40B4-BE49-F238E27FC236}">
-                <a16:creationId xmlns:a16="http://schemas.microsoft.com/office/drawing/2014/main" id="{7A341509-B507-4886-9C2F-A82F5C5994AB}"/>
+                <a16:creationId xmlns:a16="http://schemas.microsoft.com/office/drawing/2014/main" id="{C101AF96-9ED6-45E6-A1FC-ECEE69CC2A04}"/>
               </a:ext>
             </a:extLst>
           </p:cNvPr>
@@ -13273,7 +13330,7 @@
           <p:cNvPr id="6" name="">
             <a:extLst xmlns:a="http://schemas.openxmlformats.org/drawingml/2006/main">
               <a:ext uri="{FF2B5EF4-FFF2-40B4-BE49-F238E27FC236}">
-                <a16:creationId xmlns:a16="http://schemas.microsoft.com/office/drawing/2014/main" id="{AC929634-C010-4424-994D-7291175F9051}"/>
+                <a16:creationId xmlns:a16="http://schemas.microsoft.com/office/drawing/2014/main" id="{58A8CB10-1C2D-490D-8A11-FDD793BCD432}"/>
               </a:ext>
             </a:extLst>
           </p:cNvPr>
@@ -13357,7 +13414,7 @@
           <p:cNvPr id="7" name="">
             <a:extLst xmlns:a="http://schemas.openxmlformats.org/drawingml/2006/main">
               <a:ext uri="{FF2B5EF4-FFF2-40B4-BE49-F238E27FC236}">
-                <a16:creationId xmlns:a16="http://schemas.microsoft.com/office/drawing/2014/main" id="{256CBFAF-267F-41CB-A029-807491504F90}"/>
+                <a16:creationId xmlns:a16="http://schemas.microsoft.com/office/drawing/2014/main" id="{CCE4C011-3DBC-45BB-8615-B540981EE574}"/>
               </a:ext>
             </a:extLst>
           </p:cNvPr>
@@ -13387,7 +13444,7 @@
           <p:cNvPr id="8" name="">
             <a:extLst xmlns:a="http://schemas.openxmlformats.org/drawingml/2006/main">
               <a:ext uri="{FF2B5EF4-FFF2-40B4-BE49-F238E27FC236}">
-                <a16:creationId xmlns:a16="http://schemas.microsoft.com/office/drawing/2014/main" id="{2E28B35D-E8CD-407E-AF42-8422DE8EE364}"/>
+                <a16:creationId xmlns:a16="http://schemas.microsoft.com/office/drawing/2014/main" id="{A49C21F2-1E8C-406F-9EEB-2A75A5F0FB1F}"/>
               </a:ext>
             </a:extLst>
           </p:cNvPr>
@@ -13471,7 +13528,7 @@
           <p:cNvPr id="9" name="">
             <a:extLst xmlns:a="http://schemas.openxmlformats.org/drawingml/2006/main">
               <a:ext uri="{FF2B5EF4-FFF2-40B4-BE49-F238E27FC236}">
-                <a16:creationId xmlns:a16="http://schemas.microsoft.com/office/drawing/2014/main" id="{3EE10FFC-DEE6-4BC4-9C44-4E0D7D63DCD4}"/>
+                <a16:creationId xmlns:a16="http://schemas.microsoft.com/office/drawing/2014/main" id="{2C2DA7DB-73FC-4B7C-9B73-676FCBB083DD}"/>
               </a:ext>
             </a:extLst>
           </p:cNvPr>
@@ -13501,7 +13558,7 @@
           <p:cNvPr id="10" name="">
             <a:extLst xmlns:a="http://schemas.openxmlformats.org/drawingml/2006/main">
               <a:ext uri="{FF2B5EF4-FFF2-40B4-BE49-F238E27FC236}">
-                <a16:creationId xmlns:a16="http://schemas.microsoft.com/office/drawing/2014/main" id="{E81DA573-4F75-45A3-A079-950D4B7866B9}"/>
+                <a16:creationId xmlns:a16="http://schemas.microsoft.com/office/drawing/2014/main" id="{F096BB7E-A5E3-4F9F-A46D-B3007CEA9065}"/>
               </a:ext>
             </a:extLst>
           </p:cNvPr>
@@ -13585,7 +13642,7 @@
           <p:cNvPr id="11" name="">
             <a:extLst xmlns:a="http://schemas.openxmlformats.org/drawingml/2006/main">
               <a:ext uri="{FF2B5EF4-FFF2-40B4-BE49-F238E27FC236}">
-                <a16:creationId xmlns:a16="http://schemas.microsoft.com/office/drawing/2014/main" id="{B6A65DF9-545D-4DEE-AE21-E7956F0215C6}"/>
+                <a16:creationId xmlns:a16="http://schemas.microsoft.com/office/drawing/2014/main" id="{1543F806-6431-4A20-A7A8-58316B9D842B}"/>
               </a:ext>
             </a:extLst>
           </p:cNvPr>
@@ -13615,7 +13672,7 @@
           <p:cNvPr id="12" name="">
             <a:extLst xmlns:a="http://schemas.openxmlformats.org/drawingml/2006/main">
               <a:ext uri="{FF2B5EF4-FFF2-40B4-BE49-F238E27FC236}">
-                <a16:creationId xmlns:a16="http://schemas.microsoft.com/office/drawing/2014/main" id="{57DBBCDE-641A-44AF-B9D4-9C5B1B699FB7}"/>
+                <a16:creationId xmlns:a16="http://schemas.microsoft.com/office/drawing/2014/main" id="{0AA18F4D-99DC-4FD4-BB4B-A4CDE8E1EEBD}"/>
               </a:ext>
             </a:extLst>
           </p:cNvPr>
@@ -13699,7 +13756,7 @@
           <p:cNvPr id="13" name="">
             <a:extLst xmlns:a="http://schemas.openxmlformats.org/drawingml/2006/main">
               <a:ext uri="{FF2B5EF4-FFF2-40B4-BE49-F238E27FC236}">
-                <a16:creationId xmlns:a16="http://schemas.microsoft.com/office/drawing/2014/main" id="{6EAE27D5-28C3-4094-B520-AD49B250D140}"/>
+                <a16:creationId xmlns:a16="http://schemas.microsoft.com/office/drawing/2014/main" id="{66B2E97A-9378-4DA5-AC15-CF4B473AE9F2}"/>
               </a:ext>
             </a:extLst>
           </p:cNvPr>
@@ -13756,7 +13813,7 @@
           <p:cNvPr id="14" name="">
             <a:extLst xmlns:a="http://schemas.openxmlformats.org/drawingml/2006/main">
               <a:ext uri="{FF2B5EF4-FFF2-40B4-BE49-F238E27FC236}">
-                <a16:creationId xmlns:a16="http://schemas.microsoft.com/office/drawing/2014/main" id="{0D4CF290-FDBD-4508-8920-ACB1F6B2891F}"/>
+                <a16:creationId xmlns:a16="http://schemas.microsoft.com/office/drawing/2014/main" id="{6E8CBA79-413C-44BA-86FB-F8FB56321A06}"/>
               </a:ext>
             </a:extLst>
           </p:cNvPr>
@@ -13813,7 +13870,7 @@
           <p:cNvPr id="15" name="">
             <a:extLst xmlns:a="http://schemas.openxmlformats.org/drawingml/2006/main">
               <a:ext uri="{FF2B5EF4-FFF2-40B4-BE49-F238E27FC236}">
-                <a16:creationId xmlns:a16="http://schemas.microsoft.com/office/drawing/2014/main" id="{23EC6653-461B-40EF-86CC-3B8143DD04A8}"/>
+                <a16:creationId xmlns:a16="http://schemas.microsoft.com/office/drawing/2014/main" id="{B7612D6E-FB9C-4780-AF6F-99BAEC405818}"/>
               </a:ext>
             </a:extLst>
           </p:cNvPr>
@@ -13891,7 +13948,7 @@
     </p:spTree>
     <p:extLst>
       <p:ext uri="{BB962C8B-B14F-4D97-AF65-F5344CB8AC3E}">
-        <p14:creationId xmlns:p14="http://schemas.microsoft.com/office/powerpoint/2010/main" val="164389694"/>
+        <p14:creationId xmlns:p14="http://schemas.microsoft.com/office/powerpoint/2010/main" val="1292332780"/>
       </p:ext>
     </p:extLst>
   </p:cSld>
@@ -13922,7 +13979,7 @@
           <p:cNvPr id="8" name="">
             <a:extLst xmlns:a="http://schemas.openxmlformats.org/drawingml/2006/main">
               <a:ext uri="{FF2B5EF4-FFF2-40B4-BE49-F238E27FC236}">
-                <a16:creationId xmlns:a16="http://schemas.microsoft.com/office/drawing/2014/main" id="{AED390F8-D446-4535-BE70-37860E443259}"/>
+                <a16:creationId xmlns:a16="http://schemas.microsoft.com/office/drawing/2014/main" id="{FC4747B6-1F83-40C1-9E0C-3C052F2963E0}"/>
               </a:ext>
             </a:extLst>
           </p:cNvPr>
@@ -13979,7 +14036,7 @@
           <p:cNvPr id="2" name="">
             <a:extLst xmlns:a="http://schemas.openxmlformats.org/drawingml/2006/main">
               <a:ext uri="{FF2B5EF4-FFF2-40B4-BE49-F238E27FC236}">
-                <a16:creationId xmlns:a16="http://schemas.microsoft.com/office/drawing/2014/main" id="{D5601682-6D92-45F2-AFC4-A7572DEEDA30}"/>
+                <a16:creationId xmlns:a16="http://schemas.microsoft.com/office/drawing/2014/main" id="{6EAD6BD2-7E49-4156-9EC2-7A1558CF0A71}"/>
               </a:ext>
             </a:extLst>
           </p:cNvPr>
@@ -14036,7 +14093,7 @@
           <p:cNvPr id="3" name="">
             <a:extLst xmlns:a="http://schemas.openxmlformats.org/drawingml/2006/main">
               <a:ext uri="{FF2B5EF4-FFF2-40B4-BE49-F238E27FC236}">
-                <a16:creationId xmlns:a16="http://schemas.microsoft.com/office/drawing/2014/main" id="{685C25C0-5520-43E6-8617-A18403959F1C}"/>
+                <a16:creationId xmlns:a16="http://schemas.microsoft.com/office/drawing/2014/main" id="{D438F728-202B-4992-9E38-7B58346DB106}"/>
               </a:ext>
             </a:extLst>
           </p:cNvPr>
@@ -14093,7 +14150,7 @@
           <p:cNvPr id="4" name="">
             <a:extLst xmlns:a="http://schemas.openxmlformats.org/drawingml/2006/main">
               <a:ext uri="{FF2B5EF4-FFF2-40B4-BE49-F238E27FC236}">
-                <a16:creationId xmlns:a16="http://schemas.microsoft.com/office/drawing/2014/main" id="{23A61DE9-8A92-40E4-B096-0E282C7D41F3}"/>
+                <a16:creationId xmlns:a16="http://schemas.microsoft.com/office/drawing/2014/main" id="{6BE8943E-E7BB-4AB2-9388-F2BFBD1B33C2}"/>
               </a:ext>
             </a:extLst>
           </p:cNvPr>
@@ -14395,7 +14452,7 @@
           <p:cNvPr id="6" name="">
             <a:extLst xmlns:a="http://schemas.openxmlformats.org/drawingml/2006/main">
               <a:ext uri="{FF2B5EF4-FFF2-40B4-BE49-F238E27FC236}">
-                <a16:creationId xmlns:a16="http://schemas.microsoft.com/office/drawing/2014/main" id="{148FC13D-7D61-47DB-9DCD-BD067E447462}"/>
+                <a16:creationId xmlns:a16="http://schemas.microsoft.com/office/drawing/2014/main" id="{51A9D996-BC8B-4B5E-B0A6-6277D2315B12}"/>
               </a:ext>
             </a:extLst>
           </p:cNvPr>
@@ -14475,7 +14532,7 @@
           <p:cNvPr id="7" name="">
             <a:extLst xmlns:a="http://schemas.openxmlformats.org/drawingml/2006/main">
               <a:ext uri="{FF2B5EF4-FFF2-40B4-BE49-F238E27FC236}">
-                <a16:creationId xmlns:a16="http://schemas.microsoft.com/office/drawing/2014/main" id="{756CDCD8-8A46-49E9-B7D7-A44D2E03A4AC}"/>
+                <a16:creationId xmlns:a16="http://schemas.microsoft.com/office/drawing/2014/main" id="{5C37E407-1D0D-400B-A2BA-CED2E29F7624}"/>
               </a:ext>
             </a:extLst>
           </p:cNvPr>
@@ -14553,7 +14610,7 @@
     </p:spTree>
     <p:extLst>
       <p:ext uri="{BB962C8B-B14F-4D97-AF65-F5344CB8AC3E}">
-        <p14:creationId xmlns:p14="http://schemas.microsoft.com/office/powerpoint/2010/main" val="2089340210"/>
+        <p14:creationId xmlns:p14="http://schemas.microsoft.com/office/powerpoint/2010/main" val="576461496"/>
       </p:ext>
     </p:extLst>
   </p:cSld>
@@ -14584,7 +14641,7 @@
           <p:cNvPr id="7" name="">
             <a:extLst xmlns:a="http://schemas.openxmlformats.org/drawingml/2006/main">
               <a:ext uri="{FF2B5EF4-FFF2-40B4-BE49-F238E27FC236}">
-                <a16:creationId xmlns:a16="http://schemas.microsoft.com/office/drawing/2014/main" id="{737E31AB-FB1F-4F63-9E4E-EB82E9DC3949}"/>
+                <a16:creationId xmlns:a16="http://schemas.microsoft.com/office/drawing/2014/main" id="{5D2F01B0-BF90-4189-8CCB-124B0C91BA04}"/>
               </a:ext>
             </a:extLst>
           </p:cNvPr>
@@ -14641,7 +14698,7 @@
           <p:cNvPr id="2" name="">
             <a:extLst xmlns:a="http://schemas.openxmlformats.org/drawingml/2006/main">
               <a:ext uri="{FF2B5EF4-FFF2-40B4-BE49-F238E27FC236}">
-                <a16:creationId xmlns:a16="http://schemas.microsoft.com/office/drawing/2014/main" id="{219BB540-7445-466E-8E38-B9034DD9C825}"/>
+                <a16:creationId xmlns:a16="http://schemas.microsoft.com/office/drawing/2014/main" id="{BFB99386-F458-4550-BABE-5CE9F36235CC}"/>
               </a:ext>
             </a:extLst>
           </p:cNvPr>
@@ -14698,7 +14755,7 @@
           <p:cNvPr id="3" name="">
             <a:extLst xmlns:a="http://schemas.openxmlformats.org/drawingml/2006/main">
               <a:ext uri="{FF2B5EF4-FFF2-40B4-BE49-F238E27FC236}">
-                <a16:creationId xmlns:a16="http://schemas.microsoft.com/office/drawing/2014/main" id="{85913E72-7BCC-491B-8083-252A7E785641}"/>
+                <a16:creationId xmlns:a16="http://schemas.microsoft.com/office/drawing/2014/main" id="{292D7980-BDEE-4C80-8828-AC569D52E538}"/>
               </a:ext>
             </a:extLst>
           </p:cNvPr>
@@ -14755,7 +14812,7 @@
           <p:cNvPr id="4" name="">
             <a:extLst xmlns:a="http://schemas.openxmlformats.org/drawingml/2006/main">
               <a:ext uri="{FF2B5EF4-FFF2-40B4-BE49-F238E27FC236}">
-                <a16:creationId xmlns:a16="http://schemas.microsoft.com/office/drawing/2014/main" id="{1B8935AC-0370-479A-B4CE-32BFF3CE7F6A}"/>
+                <a16:creationId xmlns:a16="http://schemas.microsoft.com/office/drawing/2014/main" id="{D4892A3C-BB48-4312-8A2C-EC2906F1392C}"/>
               </a:ext>
             </a:extLst>
           </p:cNvPr>
@@ -14835,7 +14892,7 @@
           <p:cNvPr id="5" name="">
             <a:extLst xmlns:a="http://schemas.openxmlformats.org/drawingml/2006/main">
               <a:ext uri="{FF2B5EF4-FFF2-40B4-BE49-F238E27FC236}">
-                <a16:creationId xmlns:a16="http://schemas.microsoft.com/office/drawing/2014/main" id="{63DD9CCF-458B-4986-A3AF-46A877DBD8F3}"/>
+                <a16:creationId xmlns:a16="http://schemas.microsoft.com/office/drawing/2014/main" id="{26995A5D-80A5-4D78-8ADB-80E69D697A1E}"/>
               </a:ext>
             </a:extLst>
           </p:cNvPr>
@@ -14892,7 +14949,7 @@
           <p:cNvPr id="6" name="">
             <a:extLst xmlns:a="http://schemas.openxmlformats.org/drawingml/2006/main">
               <a:ext uri="{FF2B5EF4-FFF2-40B4-BE49-F238E27FC236}">
-                <a16:creationId xmlns:a16="http://schemas.microsoft.com/office/drawing/2014/main" id="{BFBE7DCD-6B54-4846-87E5-59DD0D39EB32}"/>
+                <a16:creationId xmlns:a16="http://schemas.microsoft.com/office/drawing/2014/main" id="{84355F66-CEEA-43E0-B9C8-BD75F62AA332}"/>
               </a:ext>
             </a:extLst>
           </p:cNvPr>
@@ -15016,7 +15073,7 @@
     </p:spTree>
     <p:extLst>
       <p:ext uri="{BB962C8B-B14F-4D97-AF65-F5344CB8AC3E}">
-        <p14:creationId xmlns:p14="http://schemas.microsoft.com/office/powerpoint/2010/main" val="430720217"/>
+        <p14:creationId xmlns:p14="http://schemas.microsoft.com/office/powerpoint/2010/main" val="394470385"/>
       </p:ext>
     </p:extLst>
   </p:cSld>
@@ -15047,7 +15104,7 @@
           <p:cNvPr id="6" name="">
             <a:extLst xmlns:a="http://schemas.openxmlformats.org/drawingml/2006/main">
               <a:ext uri="{FF2B5EF4-FFF2-40B4-BE49-F238E27FC236}">
-                <a16:creationId xmlns:a16="http://schemas.microsoft.com/office/drawing/2014/main" id="{FB8E2FE3-A69F-4A28-9598-CD9B7CE8B7CD}"/>
+                <a16:creationId xmlns:a16="http://schemas.microsoft.com/office/drawing/2014/main" id="{D20A99B0-A042-4426-A760-ECA0AF6C4C4E}"/>
               </a:ext>
             </a:extLst>
           </p:cNvPr>
@@ -15104,7 +15161,7 @@
           <p:cNvPr id="2" name="">
             <a:extLst xmlns:a="http://schemas.openxmlformats.org/drawingml/2006/main">
               <a:ext uri="{FF2B5EF4-FFF2-40B4-BE49-F238E27FC236}">
-                <a16:creationId xmlns:a16="http://schemas.microsoft.com/office/drawing/2014/main" id="{ECDA7C0C-604F-4877-A494-41CF4E9E15EF}"/>
+                <a16:creationId xmlns:a16="http://schemas.microsoft.com/office/drawing/2014/main" id="{A1CA4569-833D-4F1E-BECB-04D13D3BDA07}"/>
               </a:ext>
             </a:extLst>
           </p:cNvPr>
@@ -15161,7 +15218,7 @@
           <p:cNvPr id="3" name="">
             <a:extLst xmlns:a="http://schemas.openxmlformats.org/drawingml/2006/main">
               <a:ext uri="{FF2B5EF4-FFF2-40B4-BE49-F238E27FC236}">
-                <a16:creationId xmlns:a16="http://schemas.microsoft.com/office/drawing/2014/main" id="{90B86B53-4835-48BD-B16B-820E2441A72C}"/>
+                <a16:creationId xmlns:a16="http://schemas.microsoft.com/office/drawing/2014/main" id="{7FC50577-73E6-4A0B-8A77-C3C64C9188F3}"/>
               </a:ext>
             </a:extLst>
           </p:cNvPr>
@@ -15218,7 +15275,7 @@
           <p:cNvPr id="4" name="">
             <a:extLst xmlns:a="http://schemas.openxmlformats.org/drawingml/2006/main">
               <a:ext uri="{FF2B5EF4-FFF2-40B4-BE49-F238E27FC236}">
-                <a16:creationId xmlns:a16="http://schemas.microsoft.com/office/drawing/2014/main" id="{86306B76-BAF6-4597-95F1-0DF588DB1DEC}"/>
+                <a16:creationId xmlns:a16="http://schemas.microsoft.com/office/drawing/2014/main" id="{E3CA83B2-0D98-411B-94AC-A6666EA010F5}"/>
               </a:ext>
             </a:extLst>
           </p:cNvPr>
@@ -16081,7 +16138,7 @@
     </p:spTree>
     <p:extLst>
       <p:ext uri="{BB962C8B-B14F-4D97-AF65-F5344CB8AC3E}">
-        <p14:creationId xmlns:p14="http://schemas.microsoft.com/office/powerpoint/2010/main" val="308132298"/>
+        <p14:creationId xmlns:p14="http://schemas.microsoft.com/office/powerpoint/2010/main" val="480226027"/>
       </p:ext>
     </p:extLst>
   </p:cSld>
@@ -16112,7 +16169,7 @@
           <p:cNvPr id="13" name="">
             <a:extLst xmlns:a="http://schemas.openxmlformats.org/drawingml/2006/main">
               <a:ext uri="{FF2B5EF4-FFF2-40B4-BE49-F238E27FC236}">
-                <a16:creationId xmlns:a16="http://schemas.microsoft.com/office/drawing/2014/main" id="{B91AA868-5745-491E-B69B-8DDD56993B8E}"/>
+                <a16:creationId xmlns:a16="http://schemas.microsoft.com/office/drawing/2014/main" id="{7E9E37D1-C026-4F4F-9CAF-5097E4772EA3}"/>
               </a:ext>
             </a:extLst>
           </p:cNvPr>
@@ -16169,7 +16226,7 @@
           <p:cNvPr id="2" name="">
             <a:extLst xmlns:a="http://schemas.openxmlformats.org/drawingml/2006/main">
               <a:ext uri="{FF2B5EF4-FFF2-40B4-BE49-F238E27FC236}">
-                <a16:creationId xmlns:a16="http://schemas.microsoft.com/office/drawing/2014/main" id="{3FA0319F-A0DB-4A6F-AA71-07D440515FD1}"/>
+                <a16:creationId xmlns:a16="http://schemas.microsoft.com/office/drawing/2014/main" id="{F7C88D34-A1F9-42E6-AC37-6C181900F6DC}"/>
               </a:ext>
             </a:extLst>
           </p:cNvPr>
@@ -16226,7 +16283,7 @@
           <p:cNvPr id="3" name="">
             <a:extLst xmlns:a="http://schemas.openxmlformats.org/drawingml/2006/main">
               <a:ext uri="{FF2B5EF4-FFF2-40B4-BE49-F238E27FC236}">
-                <a16:creationId xmlns:a16="http://schemas.microsoft.com/office/drawing/2014/main" id="{DF24904B-2140-4FC9-A660-6F1741235A41}"/>
+                <a16:creationId xmlns:a16="http://schemas.microsoft.com/office/drawing/2014/main" id="{A093EF00-0207-45BB-B332-79ECF60324FC}"/>
               </a:ext>
             </a:extLst>
           </p:cNvPr>
@@ -16283,7 +16340,7 @@
           <p:cNvPr id="4" name="">
             <a:extLst xmlns:a="http://schemas.openxmlformats.org/drawingml/2006/main">
               <a:ext uri="{FF2B5EF4-FFF2-40B4-BE49-F238E27FC236}">
-                <a16:creationId xmlns:a16="http://schemas.microsoft.com/office/drawing/2014/main" id="{0808B5CC-2084-4511-8384-2F4D2C88AC62}"/>
+                <a16:creationId xmlns:a16="http://schemas.microsoft.com/office/drawing/2014/main" id="{35278793-D72F-4536-B39F-3D933C89BE61}"/>
               </a:ext>
             </a:extLst>
           </p:cNvPr>
@@ -16340,7 +16397,7 @@
           <p:cNvPr id="5" name="">
             <a:extLst xmlns:a="http://schemas.openxmlformats.org/drawingml/2006/main">
               <a:ext uri="{FF2B5EF4-FFF2-40B4-BE49-F238E27FC236}">
-                <a16:creationId xmlns:a16="http://schemas.microsoft.com/office/drawing/2014/main" id="{C7938744-E39C-4D54-8361-B626701565D5}"/>
+                <a16:creationId xmlns:a16="http://schemas.microsoft.com/office/drawing/2014/main" id="{9ED23B19-BE9D-4F1C-9344-181BA2F868D3}"/>
               </a:ext>
             </a:extLst>
           </p:cNvPr>
@@ -16397,7 +16454,7 @@
           <p:cNvPr id="6" name="">
             <a:extLst xmlns:a="http://schemas.openxmlformats.org/drawingml/2006/main">
               <a:ext uri="{FF2B5EF4-FFF2-40B4-BE49-F238E27FC236}">
-                <a16:creationId xmlns:a16="http://schemas.microsoft.com/office/drawing/2014/main" id="{B87D56C7-8914-481B-92D4-427FE363313E}"/>
+                <a16:creationId xmlns:a16="http://schemas.microsoft.com/office/drawing/2014/main" id="{E4F632F7-7F4B-42B6-898B-4544AF933FA4}"/>
               </a:ext>
             </a:extLst>
           </p:cNvPr>
@@ -16454,7 +16511,7 @@
           <p:cNvPr id="7" name="">
             <a:extLst xmlns:a="http://schemas.openxmlformats.org/drawingml/2006/main">
               <a:ext uri="{FF2B5EF4-FFF2-40B4-BE49-F238E27FC236}">
-                <a16:creationId xmlns:a16="http://schemas.microsoft.com/office/drawing/2014/main" id="{F010472B-6CD9-472F-A714-81C94643A2DB}"/>
+                <a16:creationId xmlns:a16="http://schemas.microsoft.com/office/drawing/2014/main" id="{2FEFEEE8-D073-4092-ACC9-2A25546B9F6B}"/>
               </a:ext>
             </a:extLst>
           </p:cNvPr>
@@ -16511,7 +16568,7 @@
           <p:cNvPr id="8" name="">
             <a:extLst xmlns:a="http://schemas.openxmlformats.org/drawingml/2006/main">
               <a:ext uri="{FF2B5EF4-FFF2-40B4-BE49-F238E27FC236}">
-                <a16:creationId xmlns:a16="http://schemas.microsoft.com/office/drawing/2014/main" id="{B5446AA0-4229-4DDE-88B2-868290B95253}"/>
+                <a16:creationId xmlns:a16="http://schemas.microsoft.com/office/drawing/2014/main" id="{B8748A0C-FB9A-4A65-8698-A34AA53C2C53}"/>
               </a:ext>
             </a:extLst>
           </p:cNvPr>
@@ -16568,7 +16625,7 @@
           <p:cNvPr id="9" name="">
             <a:extLst xmlns:a="http://schemas.openxmlformats.org/drawingml/2006/main">
               <a:ext uri="{FF2B5EF4-FFF2-40B4-BE49-F238E27FC236}">
-                <a16:creationId xmlns:a16="http://schemas.microsoft.com/office/drawing/2014/main" id="{985E7C62-FFEE-43F5-B951-D450F76B2E81}"/>
+                <a16:creationId xmlns:a16="http://schemas.microsoft.com/office/drawing/2014/main" id="{96015875-9702-446E-84F6-2AFCE6D628A0}"/>
               </a:ext>
             </a:extLst>
           </p:cNvPr>
@@ -16625,7 +16682,7 @@
           <p:cNvPr id="10" name="">
             <a:extLst xmlns:a="http://schemas.openxmlformats.org/drawingml/2006/main">
               <a:ext uri="{FF2B5EF4-FFF2-40B4-BE49-F238E27FC236}">
-                <a16:creationId xmlns:a16="http://schemas.microsoft.com/office/drawing/2014/main" id="{633634C4-14EF-4BA4-9DA9-5B20AECDA191}"/>
+                <a16:creationId xmlns:a16="http://schemas.microsoft.com/office/drawing/2014/main" id="{FDEB6CBE-DECA-40A2-A852-CD3C6BCD3895}"/>
               </a:ext>
             </a:extLst>
           </p:cNvPr>
@@ -16682,7 +16739,7 @@
           <p:cNvPr id="11" name="">
             <a:extLst xmlns:a="http://schemas.openxmlformats.org/drawingml/2006/main">
               <a:ext uri="{FF2B5EF4-FFF2-40B4-BE49-F238E27FC236}">
-                <a16:creationId xmlns:a16="http://schemas.microsoft.com/office/drawing/2014/main" id="{B7AC6C77-A3A1-4A2D-AB52-72DE1AA4650B}"/>
+                <a16:creationId xmlns:a16="http://schemas.microsoft.com/office/drawing/2014/main" id="{48E2ACB3-1A47-45F3-99C9-E8E3649AB5F2}"/>
               </a:ext>
             </a:extLst>
           </p:cNvPr>
@@ -16739,7 +16796,7 @@
           <p:cNvPr id="12" name="">
             <a:extLst xmlns:a="http://schemas.openxmlformats.org/drawingml/2006/main">
               <a:ext uri="{FF2B5EF4-FFF2-40B4-BE49-F238E27FC236}">
-                <a16:creationId xmlns:a16="http://schemas.microsoft.com/office/drawing/2014/main" id="{70767E2B-C36E-4B4A-B125-CCD9B73D4142}"/>
+                <a16:creationId xmlns:a16="http://schemas.microsoft.com/office/drawing/2014/main" id="{B5459D4A-FE11-416C-9264-966D0E16DA09}"/>
               </a:ext>
             </a:extLst>
           </p:cNvPr>
@@ -16794,7 +16851,7 @@
     </p:spTree>
     <p:extLst>
       <p:ext uri="{BB962C8B-B14F-4D97-AF65-F5344CB8AC3E}">
-        <p14:creationId xmlns:p14="http://schemas.microsoft.com/office/powerpoint/2010/main" val="1199435076"/>
+        <p14:creationId xmlns:p14="http://schemas.microsoft.com/office/powerpoint/2010/main" val="1909700487"/>
       </p:ext>
     </p:extLst>
   </p:cSld>
@@ -16825,7 +16882,7 @@
           <p:cNvPr id="7" name="">
             <a:extLst xmlns:a="http://schemas.openxmlformats.org/drawingml/2006/main">
               <a:ext uri="{FF2B5EF4-FFF2-40B4-BE49-F238E27FC236}">
-                <a16:creationId xmlns:a16="http://schemas.microsoft.com/office/drawing/2014/main" id="{639826D3-23A7-4A4D-82AD-2244F3E8C763}"/>
+                <a16:creationId xmlns:a16="http://schemas.microsoft.com/office/drawing/2014/main" id="{03457C29-5741-4F1A-8C31-40347780D376}"/>
               </a:ext>
             </a:extLst>
           </p:cNvPr>
@@ -16882,7 +16939,7 @@
           <p:cNvPr id="2" name="">
             <a:extLst xmlns:a="http://schemas.openxmlformats.org/drawingml/2006/main">
               <a:ext uri="{FF2B5EF4-FFF2-40B4-BE49-F238E27FC236}">
-                <a16:creationId xmlns:a16="http://schemas.microsoft.com/office/drawing/2014/main" id="{FA09901D-CFD8-4F69-8982-EA9048840FEF}"/>
+                <a16:creationId xmlns:a16="http://schemas.microsoft.com/office/drawing/2014/main" id="{5276989B-2E97-4AA0-81D4-5ADA99B89238}"/>
               </a:ext>
             </a:extLst>
           </p:cNvPr>
@@ -16939,7 +16996,7 @@
           <p:cNvPr id="3" name="">
             <a:extLst xmlns:a="http://schemas.openxmlformats.org/drawingml/2006/main">
               <a:ext uri="{FF2B5EF4-FFF2-40B4-BE49-F238E27FC236}">
-                <a16:creationId xmlns:a16="http://schemas.microsoft.com/office/drawing/2014/main" id="{A94F3911-06BC-4741-AE87-5259ED0D813D}"/>
+                <a16:creationId xmlns:a16="http://schemas.microsoft.com/office/drawing/2014/main" id="{CB6254C0-9314-4DD1-AE4D-D18D164B60DF}"/>
               </a:ext>
             </a:extLst>
           </p:cNvPr>
@@ -17314,7 +17371,7 @@
           <p:cNvPr id="5" name="">
             <a:extLst xmlns:a="http://schemas.openxmlformats.org/drawingml/2006/main">
               <a:ext uri="{FF2B5EF4-FFF2-40B4-BE49-F238E27FC236}">
-                <a16:creationId xmlns:a16="http://schemas.microsoft.com/office/drawing/2014/main" id="{06A28B57-9FEF-4DD3-9812-3F153D7B290C}"/>
+                <a16:creationId xmlns:a16="http://schemas.microsoft.com/office/drawing/2014/main" id="{8E2D6608-E1D8-4426-9247-9A4B7316658C}"/>
               </a:ext>
             </a:extLst>
           </p:cNvPr>
@@ -17394,7 +17451,7 @@
           <p:cNvPr id="6" name="">
             <a:extLst xmlns:a="http://schemas.openxmlformats.org/drawingml/2006/main">
               <a:ext uri="{FF2B5EF4-FFF2-40B4-BE49-F238E27FC236}">
-                <a16:creationId xmlns:a16="http://schemas.microsoft.com/office/drawing/2014/main" id="{5D4E0E9C-400D-49A5-9916-43EF4D40D7E2}"/>
+                <a16:creationId xmlns:a16="http://schemas.microsoft.com/office/drawing/2014/main" id="{CC491EA7-12AD-471C-8A25-28E26AAD47FB}"/>
               </a:ext>
             </a:extLst>
           </p:cNvPr>
@@ -17472,7 +17529,7 @@
     </p:spTree>
     <p:extLst>
       <p:ext uri="{BB962C8B-B14F-4D97-AF65-F5344CB8AC3E}">
-        <p14:creationId xmlns:p14="http://schemas.microsoft.com/office/powerpoint/2010/main" val="1592329215"/>
+        <p14:creationId xmlns:p14="http://schemas.microsoft.com/office/powerpoint/2010/main" val="470054644"/>
       </p:ext>
     </p:extLst>
   </p:cSld>
@@ -17503,7 +17560,7 @@
           <p:cNvPr id="14" name="">
             <a:extLst xmlns:a="http://schemas.openxmlformats.org/drawingml/2006/main">
               <a:ext uri="{FF2B5EF4-FFF2-40B4-BE49-F238E27FC236}">
-                <a16:creationId xmlns:a16="http://schemas.microsoft.com/office/drawing/2014/main" id="{14CBF922-42EC-48E8-A1E5-E047B6424234}"/>
+                <a16:creationId xmlns:a16="http://schemas.microsoft.com/office/drawing/2014/main" id="{DB4BAF46-5865-4AE6-BF83-9C76CF67F45D}"/>
               </a:ext>
             </a:extLst>
           </p:cNvPr>
@@ -17560,7 +17617,7 @@
           <p:cNvPr id="2" name="">
             <a:extLst xmlns:a="http://schemas.openxmlformats.org/drawingml/2006/main">
               <a:ext uri="{FF2B5EF4-FFF2-40B4-BE49-F238E27FC236}">
-                <a16:creationId xmlns:a16="http://schemas.microsoft.com/office/drawing/2014/main" id="{D8836220-3B37-4F08-8D8B-838BBADAA721}"/>
+                <a16:creationId xmlns:a16="http://schemas.microsoft.com/office/drawing/2014/main" id="{321CE4A2-7B9C-4EDF-816C-096BD328D39E}"/>
               </a:ext>
             </a:extLst>
           </p:cNvPr>
@@ -17617,7 +17674,7 @@
           <p:cNvPr id="3" name="">
             <a:extLst xmlns:a="http://schemas.openxmlformats.org/drawingml/2006/main">
               <a:ext uri="{FF2B5EF4-FFF2-40B4-BE49-F238E27FC236}">
-                <a16:creationId xmlns:a16="http://schemas.microsoft.com/office/drawing/2014/main" id="{B6FCB86A-B240-4050-99F3-846E2BF5C4A6}"/>
+                <a16:creationId xmlns:a16="http://schemas.microsoft.com/office/drawing/2014/main" id="{0D3A81C1-3BC0-4C34-9DD0-9D3345DAE17A}"/>
               </a:ext>
             </a:extLst>
           </p:cNvPr>
@@ -17674,7 +17731,7 @@
           <p:cNvPr id="4" name="">
             <a:extLst xmlns:a="http://schemas.openxmlformats.org/drawingml/2006/main">
               <a:ext uri="{FF2B5EF4-FFF2-40B4-BE49-F238E27FC236}">
-                <a16:creationId xmlns:a16="http://schemas.microsoft.com/office/drawing/2014/main" id="{58C403C3-9499-4100-9E38-15E1FFC1575A}"/>
+                <a16:creationId xmlns:a16="http://schemas.microsoft.com/office/drawing/2014/main" id="{E8324AF3-26C3-43D5-A6C8-7ED97082699B}"/>
               </a:ext>
             </a:extLst>
           </p:cNvPr>
@@ -17731,7 +17788,7 @@
           <p:cNvPr id="5" name="">
             <a:extLst xmlns:a="http://schemas.openxmlformats.org/drawingml/2006/main">
               <a:ext uri="{FF2B5EF4-FFF2-40B4-BE49-F238E27FC236}">
-                <a16:creationId xmlns:a16="http://schemas.microsoft.com/office/drawing/2014/main" id="{1062CDC3-9BBB-4FC2-A3E6-E010C9DFE5C9}"/>
+                <a16:creationId xmlns:a16="http://schemas.microsoft.com/office/drawing/2014/main" id="{EE660DD4-F421-44E0-8FAD-85E57EAEB82E}"/>
               </a:ext>
             </a:extLst>
           </p:cNvPr>
@@ -17788,7 +17845,7 @@
           <p:cNvPr id="6" name="">
             <a:extLst xmlns:a="http://schemas.openxmlformats.org/drawingml/2006/main">
               <a:ext uri="{FF2B5EF4-FFF2-40B4-BE49-F238E27FC236}">
-                <a16:creationId xmlns:a16="http://schemas.microsoft.com/office/drawing/2014/main" id="{98B274EC-4BB3-42DD-AB18-EBD24C592202}"/>
+                <a16:creationId xmlns:a16="http://schemas.microsoft.com/office/drawing/2014/main" id="{85AC3E14-3923-43E0-8F6A-D64895819AA7}"/>
               </a:ext>
             </a:extLst>
           </p:cNvPr>
@@ -17868,7 +17925,7 @@
           <p:cNvPr id="7" name="">
             <a:extLst xmlns:a="http://schemas.openxmlformats.org/drawingml/2006/main">
               <a:ext uri="{FF2B5EF4-FFF2-40B4-BE49-F238E27FC236}">
-                <a16:creationId xmlns:a16="http://schemas.microsoft.com/office/drawing/2014/main" id="{465F1BD8-8F62-4B28-BB5A-F3C42C05E89B}"/>
+                <a16:creationId xmlns:a16="http://schemas.microsoft.com/office/drawing/2014/main" id="{5C0459A4-31F8-44FD-AABC-4CD9A51324B3}"/>
               </a:ext>
             </a:extLst>
           </p:cNvPr>
@@ -17925,7 +17982,7 @@
           <p:cNvPr id="8" name="">
             <a:extLst xmlns:a="http://schemas.openxmlformats.org/drawingml/2006/main">
               <a:ext uri="{FF2B5EF4-FFF2-40B4-BE49-F238E27FC236}">
-                <a16:creationId xmlns:a16="http://schemas.microsoft.com/office/drawing/2014/main" id="{2CA6A5E0-33E8-4A21-A308-06A21490004B}"/>
+                <a16:creationId xmlns:a16="http://schemas.microsoft.com/office/drawing/2014/main" id="{BE4F0D18-D69B-4AE5-8F8F-97A43EDEE088}"/>
               </a:ext>
             </a:extLst>
           </p:cNvPr>
@@ -17982,7 +18039,7 @@
           <p:cNvPr id="9" name="">
             <a:extLst xmlns:a="http://schemas.openxmlformats.org/drawingml/2006/main">
               <a:ext uri="{FF2B5EF4-FFF2-40B4-BE49-F238E27FC236}">
-                <a16:creationId xmlns:a16="http://schemas.microsoft.com/office/drawing/2014/main" id="{21421B83-8277-4C2A-9736-304527C834C6}"/>
+                <a16:creationId xmlns:a16="http://schemas.microsoft.com/office/drawing/2014/main" id="{CCE30D09-2B17-48C1-A745-42410B364015}"/>
               </a:ext>
             </a:extLst>
           </p:cNvPr>
@@ -18062,7 +18119,7 @@
           <p:cNvPr id="10" name="">
             <a:extLst xmlns:a="http://schemas.openxmlformats.org/drawingml/2006/main">
               <a:ext uri="{FF2B5EF4-FFF2-40B4-BE49-F238E27FC236}">
-                <a16:creationId xmlns:a16="http://schemas.microsoft.com/office/drawing/2014/main" id="{71C6AF39-97E8-4E7B-9B57-0AFF60BA1EA0}"/>
+                <a16:creationId xmlns:a16="http://schemas.microsoft.com/office/drawing/2014/main" id="{B6219601-3783-41D0-89B0-EEB115042E6B}"/>
               </a:ext>
             </a:extLst>
           </p:cNvPr>
@@ -18119,7 +18176,7 @@
           <p:cNvPr id="11" name="">
             <a:extLst xmlns:a="http://schemas.openxmlformats.org/drawingml/2006/main">
               <a:ext uri="{FF2B5EF4-FFF2-40B4-BE49-F238E27FC236}">
-                <a16:creationId xmlns:a16="http://schemas.microsoft.com/office/drawing/2014/main" id="{C49A2728-66E9-4AEE-8211-A4F0C0E29836}"/>
+                <a16:creationId xmlns:a16="http://schemas.microsoft.com/office/drawing/2014/main" id="{515EF0A9-4E60-4FAE-A6FB-29368AF659EB}"/>
               </a:ext>
             </a:extLst>
           </p:cNvPr>
@@ -18176,7 +18233,7 @@
           <p:cNvPr id="12" name="">
             <a:extLst xmlns:a="http://schemas.openxmlformats.org/drawingml/2006/main">
               <a:ext uri="{FF2B5EF4-FFF2-40B4-BE49-F238E27FC236}">
-                <a16:creationId xmlns:a16="http://schemas.microsoft.com/office/drawing/2014/main" id="{937B7776-C125-4673-8E8E-E2CF0C09E349}"/>
+                <a16:creationId xmlns:a16="http://schemas.microsoft.com/office/drawing/2014/main" id="{A218D6A6-0F43-4B5A-BFB8-A0FAF31A509B}"/>
               </a:ext>
             </a:extLst>
           </p:cNvPr>
@@ -18256,7 +18313,7 @@
           <p:cNvPr id="13" name="">
             <a:extLst xmlns:a="http://schemas.openxmlformats.org/drawingml/2006/main">
               <a:ext uri="{FF2B5EF4-FFF2-40B4-BE49-F238E27FC236}">
-                <a16:creationId xmlns:a16="http://schemas.microsoft.com/office/drawing/2014/main" id="{DBC3E99E-BA3E-409D-94B8-BC60F312B8E7}"/>
+                <a16:creationId xmlns:a16="http://schemas.microsoft.com/office/drawing/2014/main" id="{99696150-A368-4DF8-B671-D7F55CFADBAF}"/>
               </a:ext>
             </a:extLst>
           </p:cNvPr>
@@ -18334,7 +18391,7 @@
     </p:spTree>
     <p:extLst>
       <p:ext uri="{BB962C8B-B14F-4D97-AF65-F5344CB8AC3E}">
-        <p14:creationId xmlns:p14="http://schemas.microsoft.com/office/powerpoint/2010/main" val="1650053841"/>
+        <p14:creationId xmlns:p14="http://schemas.microsoft.com/office/powerpoint/2010/main" val="1377509077"/>
       </p:ext>
     </p:extLst>
   </p:cSld>
@@ -18365,7 +18422,7 @@
           <p:cNvPr id="8" name="">
             <a:extLst xmlns:a="http://schemas.openxmlformats.org/drawingml/2006/main">
               <a:ext uri="{FF2B5EF4-FFF2-40B4-BE49-F238E27FC236}">
-                <a16:creationId xmlns:a16="http://schemas.microsoft.com/office/drawing/2014/main" id="{8406342E-C36A-405E-A7BD-3D1456659AA4}"/>
+                <a16:creationId xmlns:a16="http://schemas.microsoft.com/office/drawing/2014/main" id="{DDCC36A6-A38A-4120-AFF7-F48541E6AD91}"/>
               </a:ext>
             </a:extLst>
           </p:cNvPr>
@@ -18422,7 +18479,7 @@
           <p:cNvPr id="2" name="">
             <a:extLst xmlns:a="http://schemas.openxmlformats.org/drawingml/2006/main">
               <a:ext uri="{FF2B5EF4-FFF2-40B4-BE49-F238E27FC236}">
-                <a16:creationId xmlns:a16="http://schemas.microsoft.com/office/drawing/2014/main" id="{49A3929B-C782-4E7F-BF43-10B08FC88678}"/>
+                <a16:creationId xmlns:a16="http://schemas.microsoft.com/office/drawing/2014/main" id="{CC9FE8A6-014C-4D34-9DA7-764BF8BBAE97}"/>
               </a:ext>
             </a:extLst>
           </p:cNvPr>
@@ -18479,7 +18536,7 @@
           <p:cNvPr id="3" name="">
             <a:extLst xmlns:a="http://schemas.openxmlformats.org/drawingml/2006/main">
               <a:ext uri="{FF2B5EF4-FFF2-40B4-BE49-F238E27FC236}">
-                <a16:creationId xmlns:a16="http://schemas.microsoft.com/office/drawing/2014/main" id="{EF1395CC-40C3-4951-8033-B628359B4F03}"/>
+                <a16:creationId xmlns:a16="http://schemas.microsoft.com/office/drawing/2014/main" id="{C9829C6C-99A9-449F-A4C0-12A5D4BB4DC2}"/>
               </a:ext>
             </a:extLst>
           </p:cNvPr>
@@ -18540,7 +18597,7 @@
           <p:nvPr/>
         </p:nvPicPr>
         <p:blipFill>
-          <a:blip xmlns:r="http://schemas.openxmlformats.org/officeDocument/2006/relationships" xmlns:a="http://schemas.openxmlformats.org/drawingml/2006/main" r:embed="R9760d1bf9d8442b2"/>
+          <a:blip xmlns:r="http://schemas.openxmlformats.org/officeDocument/2006/relationships" xmlns:a="http://schemas.openxmlformats.org/drawingml/2006/main" r:embed="R3b70dd7262fa4aba"/>
           <a:stretch xmlns:a="http://schemas.openxmlformats.org/drawingml/2006/main"/>
         </p:blipFill>
         <p:spPr>
@@ -18558,7 +18615,7 @@
           <p:cNvPr id="5" name="">
             <a:extLst xmlns:a="http://schemas.openxmlformats.org/drawingml/2006/main">
               <a:ext uri="{FF2B5EF4-FFF2-40B4-BE49-F238E27FC236}">
-                <a16:creationId xmlns:a16="http://schemas.microsoft.com/office/drawing/2014/main" id="{4121B817-3749-4F45-AE27-E0AC14297C4B}"/>
+                <a16:creationId xmlns:a16="http://schemas.microsoft.com/office/drawing/2014/main" id="{FCC426B9-4812-4C76-8AD3-4AE17E9868E2}"/>
               </a:ext>
             </a:extLst>
           </p:cNvPr>
@@ -18638,7 +18695,7 @@
           <p:cNvPr id="6" name="">
             <a:extLst xmlns:a="http://schemas.openxmlformats.org/drawingml/2006/main">
               <a:ext uri="{FF2B5EF4-FFF2-40B4-BE49-F238E27FC236}">
-                <a16:creationId xmlns:a16="http://schemas.microsoft.com/office/drawing/2014/main" id="{CA96E9E7-7701-4FFF-AFCF-31F4FE99D2FE}"/>
+                <a16:creationId xmlns:a16="http://schemas.microsoft.com/office/drawing/2014/main" id="{66DC0E67-A85F-4BB9-9E20-6C09B8C1A08C}"/>
               </a:ext>
             </a:extLst>
           </p:cNvPr>
@@ -18718,7 +18775,7 @@
           <p:cNvPr id="7" name="">
             <a:extLst xmlns:a="http://schemas.openxmlformats.org/drawingml/2006/main">
               <a:ext uri="{FF2B5EF4-FFF2-40B4-BE49-F238E27FC236}">
-                <a16:creationId xmlns:a16="http://schemas.microsoft.com/office/drawing/2014/main" id="{0E2C576D-8371-4E62-8379-D03CAABCCC24}"/>
+                <a16:creationId xmlns:a16="http://schemas.microsoft.com/office/drawing/2014/main" id="{DCEBE82B-5F47-48F1-9D24-351FA0D0F75A}"/>
               </a:ext>
             </a:extLst>
           </p:cNvPr>
@@ -18796,7 +18853,7 @@
     </p:spTree>
     <p:extLst>
       <p:ext uri="{BB962C8B-B14F-4D97-AF65-F5344CB8AC3E}">
-        <p14:creationId xmlns:p14="http://schemas.microsoft.com/office/powerpoint/2010/main" val="1604107358"/>
+        <p14:creationId xmlns:p14="http://schemas.microsoft.com/office/powerpoint/2010/main" val="921714416"/>
       </p:ext>
     </p:extLst>
   </p:cSld>
@@ -18827,7 +18884,7 @@
           <p:cNvPr id="9" name="">
             <a:extLst xmlns:a="http://schemas.openxmlformats.org/drawingml/2006/main">
               <a:ext uri="{FF2B5EF4-FFF2-40B4-BE49-F238E27FC236}">
-                <a16:creationId xmlns:a16="http://schemas.microsoft.com/office/drawing/2014/main" id="{042C8FB8-7133-4AD3-BAEC-85FE72D4EA78}"/>
+                <a16:creationId xmlns:a16="http://schemas.microsoft.com/office/drawing/2014/main" id="{79ADF6C9-8BC2-42B5-B18D-B18A15AA781D}"/>
               </a:ext>
             </a:extLst>
           </p:cNvPr>
@@ -18884,7 +18941,7 @@
           <p:cNvPr id="2" name="">
             <a:extLst xmlns:a="http://schemas.openxmlformats.org/drawingml/2006/main">
               <a:ext uri="{FF2B5EF4-FFF2-40B4-BE49-F238E27FC236}">
-                <a16:creationId xmlns:a16="http://schemas.microsoft.com/office/drawing/2014/main" id="{6CB9D363-AC65-4FEC-B55F-DE28B13F4350}"/>
+                <a16:creationId xmlns:a16="http://schemas.microsoft.com/office/drawing/2014/main" id="{3D67FD39-288E-4D96-B648-513A4D1F8DC5}"/>
               </a:ext>
             </a:extLst>
           </p:cNvPr>
@@ -18941,7 +18998,7 @@
           <p:cNvPr id="3" name="">
             <a:extLst xmlns:a="http://schemas.openxmlformats.org/drawingml/2006/main">
               <a:ext uri="{FF2B5EF4-FFF2-40B4-BE49-F238E27FC236}">
-                <a16:creationId xmlns:a16="http://schemas.microsoft.com/office/drawing/2014/main" id="{E46B5C33-0572-4C58-A714-C6F40CD5873F}"/>
+                <a16:creationId xmlns:a16="http://schemas.microsoft.com/office/drawing/2014/main" id="{FC677D80-8DB2-466F-B71C-DCD88404C0D7}"/>
               </a:ext>
             </a:extLst>
           </p:cNvPr>
@@ -18998,7 +19055,7 @@
           <p:cNvPr id="4" name="">
             <a:extLst xmlns:a="http://schemas.openxmlformats.org/drawingml/2006/main">
               <a:ext uri="{FF2B5EF4-FFF2-40B4-BE49-F238E27FC236}">
-                <a16:creationId xmlns:a16="http://schemas.microsoft.com/office/drawing/2014/main" id="{FF8C1CFA-46BA-4265-BDE4-B3281D21976F}"/>
+                <a16:creationId xmlns:a16="http://schemas.microsoft.com/office/drawing/2014/main" id="{5CBF0CDE-54B6-4B9D-8F32-6C8F157766B8}"/>
               </a:ext>
             </a:extLst>
           </p:cNvPr>
@@ -19062,7 +19119,7 @@
         </p:xfrm>
         <a:graphic xmlns:a="http://schemas.openxmlformats.org/drawingml/2006/main">
           <a:graphicData uri="http://schemas.openxmlformats.org/drawingml/2006/chart">
-            <c:chart xmlns:r="http://schemas.openxmlformats.org/officeDocument/2006/relationships" xmlns:c="http://schemas.openxmlformats.org/drawingml/2006/chart" r:id="R4191729207474cd2"/>
+            <c:chart xmlns:r="http://schemas.openxmlformats.org/officeDocument/2006/relationships" xmlns:c="http://schemas.openxmlformats.org/drawingml/2006/chart" r:id="R350faa30c2924a4b"/>
           </a:graphicData>
         </a:graphic>
       </p:graphicFrame>
@@ -19071,7 +19128,7 @@
           <p:cNvPr id="6" name="">
             <a:extLst xmlns:a="http://schemas.openxmlformats.org/drawingml/2006/main">
               <a:ext uri="{FF2B5EF4-FFF2-40B4-BE49-F238E27FC236}">
-                <a16:creationId xmlns:a16="http://schemas.microsoft.com/office/drawing/2014/main" id="{CAF5033B-B8A2-4046-8601-F5105AA9BBBC}"/>
+                <a16:creationId xmlns:a16="http://schemas.microsoft.com/office/drawing/2014/main" id="{1B68522D-D4C5-478B-A5D6-C2DB48CEC804}"/>
               </a:ext>
             </a:extLst>
           </p:cNvPr>
@@ -20760,7 +20817,7 @@
           <p:cNvPr id="8" name="">
             <a:extLst xmlns:a="http://schemas.openxmlformats.org/drawingml/2006/main">
               <a:ext uri="{FF2B5EF4-FFF2-40B4-BE49-F238E27FC236}">
-                <a16:creationId xmlns:a16="http://schemas.microsoft.com/office/drawing/2014/main" id="{EC62B12B-B2BA-4544-AC62-6BCE8D6004B9}"/>
+                <a16:creationId xmlns:a16="http://schemas.microsoft.com/office/drawing/2014/main" id="{CB4234CA-A5A5-41F9-ABA6-14121840AB73}"/>
               </a:ext>
             </a:extLst>
           </p:cNvPr>
@@ -20838,7 +20895,7 @@
     </p:spTree>
     <p:extLst>
       <p:ext uri="{BB962C8B-B14F-4D97-AF65-F5344CB8AC3E}">
-        <p14:creationId xmlns:p14="http://schemas.microsoft.com/office/powerpoint/2010/main" val="1290406625"/>
+        <p14:creationId xmlns:p14="http://schemas.microsoft.com/office/powerpoint/2010/main" val="138455769"/>
       </p:ext>
     </p:extLst>
   </p:cSld>
@@ -20869,7 +20926,7 @@
           <p:cNvPr id="7" name="">
             <a:extLst xmlns:a="http://schemas.openxmlformats.org/drawingml/2006/main">
               <a:ext uri="{FF2B5EF4-FFF2-40B4-BE49-F238E27FC236}">
-                <a16:creationId xmlns:a16="http://schemas.microsoft.com/office/drawing/2014/main" id="{90C4A97E-E276-4DA7-8976-4E4C476E790F}"/>
+                <a16:creationId xmlns:a16="http://schemas.microsoft.com/office/drawing/2014/main" id="{64C1B4E6-45BA-4290-97E8-2468B3EB89C1}"/>
               </a:ext>
             </a:extLst>
           </p:cNvPr>
@@ -20926,7 +20983,7 @@
           <p:cNvPr id="2" name="">
             <a:extLst xmlns:a="http://schemas.openxmlformats.org/drawingml/2006/main">
               <a:ext uri="{FF2B5EF4-FFF2-40B4-BE49-F238E27FC236}">
-                <a16:creationId xmlns:a16="http://schemas.microsoft.com/office/drawing/2014/main" id="{97ABA1BB-7D5D-4873-8FBB-90D4654E68B5}"/>
+                <a16:creationId xmlns:a16="http://schemas.microsoft.com/office/drawing/2014/main" id="{ADB47063-6AE5-40B8-992D-2160A5F89C30}"/>
               </a:ext>
             </a:extLst>
           </p:cNvPr>
@@ -20983,7 +21040,7 @@
           <p:cNvPr id="3" name="">
             <a:extLst xmlns:a="http://schemas.openxmlformats.org/drawingml/2006/main">
               <a:ext uri="{FF2B5EF4-FFF2-40B4-BE49-F238E27FC236}">
-                <a16:creationId xmlns:a16="http://schemas.microsoft.com/office/drawing/2014/main" id="{2AEC542A-D575-4292-819C-8EF0F3D89478}"/>
+                <a16:creationId xmlns:a16="http://schemas.microsoft.com/office/drawing/2014/main" id="{C9F952B9-4CF1-439C-A037-E686ED4743B5}"/>
               </a:ext>
             </a:extLst>
           </p:cNvPr>
@@ -21433,7 +21490,7 @@
           <p:cNvPr id="5" name="">
             <a:extLst xmlns:a="http://schemas.openxmlformats.org/drawingml/2006/main">
               <a:ext uri="{FF2B5EF4-FFF2-40B4-BE49-F238E27FC236}">
-                <a16:creationId xmlns:a16="http://schemas.microsoft.com/office/drawing/2014/main" id="{55089365-0F61-4834-977F-E7A3A6B27AB2}"/>
+                <a16:creationId xmlns:a16="http://schemas.microsoft.com/office/drawing/2014/main" id="{6EDDDD2A-56F1-455A-A80E-83439E9663DB}"/>
               </a:ext>
             </a:extLst>
           </p:cNvPr>
@@ -21513,7 +21570,7 @@
           <p:cNvPr id="6" name="">
             <a:extLst xmlns:a="http://schemas.openxmlformats.org/drawingml/2006/main">
               <a:ext uri="{FF2B5EF4-FFF2-40B4-BE49-F238E27FC236}">
-                <a16:creationId xmlns:a16="http://schemas.microsoft.com/office/drawing/2014/main" id="{0275B108-EA5B-48A9-9D55-8D3D8BF14E0A}"/>
+                <a16:creationId xmlns:a16="http://schemas.microsoft.com/office/drawing/2014/main" id="{2BF9E1F1-EA93-4210-95F3-CAC1113AD20E}"/>
               </a:ext>
             </a:extLst>
           </p:cNvPr>
@@ -21591,7 +21648,7 @@
     </p:spTree>
     <p:extLst>
       <p:ext uri="{BB962C8B-B14F-4D97-AF65-F5344CB8AC3E}">
-        <p14:creationId xmlns:p14="http://schemas.microsoft.com/office/powerpoint/2010/main" val="1963953868"/>
+        <p14:creationId xmlns:p14="http://schemas.microsoft.com/office/powerpoint/2010/main" val="1504679885"/>
       </p:ext>
     </p:extLst>
   </p:cSld>
@@ -21622,7 +21679,7 @@
           <p:cNvPr id="5" name="">
             <a:extLst xmlns:a="http://schemas.openxmlformats.org/drawingml/2006/main">
               <a:ext uri="{FF2B5EF4-FFF2-40B4-BE49-F238E27FC236}">
-                <a16:creationId xmlns:a16="http://schemas.microsoft.com/office/drawing/2014/main" id="{47F96064-9343-40AC-853F-58005B40A290}"/>
+                <a16:creationId xmlns:a16="http://schemas.microsoft.com/office/drawing/2014/main" id="{4AC8CC3C-918C-4F64-BAD9-1E8AFE73934A}"/>
               </a:ext>
             </a:extLst>
           </p:cNvPr>
@@ -21679,7 +21736,7 @@
           <p:cNvPr id="2" name="">
             <a:extLst xmlns:a="http://schemas.openxmlformats.org/drawingml/2006/main">
               <a:ext uri="{FF2B5EF4-FFF2-40B4-BE49-F238E27FC236}">
-                <a16:creationId xmlns:a16="http://schemas.microsoft.com/office/drawing/2014/main" id="{BE5FFED3-F52A-42AA-A9D7-860F962A8AD5}"/>
+                <a16:creationId xmlns:a16="http://schemas.microsoft.com/office/drawing/2014/main" id="{F2AABECA-830B-43C1-B416-E456378772F4}"/>
               </a:ext>
             </a:extLst>
           </p:cNvPr>
@@ -21736,7 +21793,7 @@
           <p:cNvPr id="3" name="">
             <a:extLst xmlns:a="http://schemas.openxmlformats.org/drawingml/2006/main">
               <a:ext uri="{FF2B5EF4-FFF2-40B4-BE49-F238E27FC236}">
-                <a16:creationId xmlns:a16="http://schemas.microsoft.com/office/drawing/2014/main" id="{FE1B6490-5203-4D4B-9641-D8E27978662C}"/>
+                <a16:creationId xmlns:a16="http://schemas.microsoft.com/office/drawing/2014/main" id="{FF5A472F-99F2-42F3-8942-6A5CA65B13B4}"/>
               </a:ext>
             </a:extLst>
           </p:cNvPr>
@@ -22406,7 +22463,7 @@
     </p:spTree>
     <p:extLst>
       <p:ext uri="{BB962C8B-B14F-4D97-AF65-F5344CB8AC3E}">
-        <p14:creationId xmlns:p14="http://schemas.microsoft.com/office/powerpoint/2010/main" val="806228499"/>
+        <p14:creationId xmlns:p14="http://schemas.microsoft.com/office/powerpoint/2010/main" val="441630359"/>
       </p:ext>
     </p:extLst>
   </p:cSld>
@@ -22437,7 +22494,7 @@
           <p:cNvPr id="7" name="">
             <a:extLst xmlns:a="http://schemas.openxmlformats.org/drawingml/2006/main">
               <a:ext uri="{FF2B5EF4-FFF2-40B4-BE49-F238E27FC236}">
-                <a16:creationId xmlns:a16="http://schemas.microsoft.com/office/drawing/2014/main" id="{9D7430EE-DF31-40AC-ABC8-B0E5FB5D24A6}"/>
+                <a16:creationId xmlns:a16="http://schemas.microsoft.com/office/drawing/2014/main" id="{A6501506-7A6A-459C-BCE0-1E482FBE2AA5}"/>
               </a:ext>
             </a:extLst>
           </p:cNvPr>
@@ -22494,7 +22551,7 @@
           <p:cNvPr id="2" name="">
             <a:extLst xmlns:a="http://schemas.openxmlformats.org/drawingml/2006/main">
               <a:ext uri="{FF2B5EF4-FFF2-40B4-BE49-F238E27FC236}">
-                <a16:creationId xmlns:a16="http://schemas.microsoft.com/office/drawing/2014/main" id="{83668297-91C0-466F-9FAC-CB75F7704339}"/>
+                <a16:creationId xmlns:a16="http://schemas.microsoft.com/office/drawing/2014/main" id="{3D6F7093-EC83-4011-8AF7-B41EFAFC48EE}"/>
               </a:ext>
             </a:extLst>
           </p:cNvPr>
@@ -22551,7 +22608,7 @@
           <p:cNvPr id="3" name="">
             <a:extLst xmlns:a="http://schemas.openxmlformats.org/drawingml/2006/main">
               <a:ext uri="{FF2B5EF4-FFF2-40B4-BE49-F238E27FC236}">
-                <a16:creationId xmlns:a16="http://schemas.microsoft.com/office/drawing/2014/main" id="{7DF72130-AE74-448A-875E-4B55C80AF827}"/>
+                <a16:creationId xmlns:a16="http://schemas.microsoft.com/office/drawing/2014/main" id="{085AA4D9-3CFA-4A6B-8ED1-55A2E2D89E58}"/>
               </a:ext>
             </a:extLst>
           </p:cNvPr>
@@ -23121,7 +23178,7 @@
           <p:cNvPr id="5" name="">
             <a:extLst xmlns:a="http://schemas.openxmlformats.org/drawingml/2006/main">
               <a:ext uri="{FF2B5EF4-FFF2-40B4-BE49-F238E27FC236}">
-                <a16:creationId xmlns:a16="http://schemas.microsoft.com/office/drawing/2014/main" id="{3837AE45-33DE-4D90-84D0-B87C575FEDD5}"/>
+                <a16:creationId xmlns:a16="http://schemas.microsoft.com/office/drawing/2014/main" id="{8EEBC46A-6B4A-4820-9D35-E5B95311C7BD}"/>
               </a:ext>
             </a:extLst>
           </p:cNvPr>
@@ -23201,7 +23258,7 @@
           <p:cNvPr id="6" name="">
             <a:extLst xmlns:a="http://schemas.openxmlformats.org/drawingml/2006/main">
               <a:ext uri="{FF2B5EF4-FFF2-40B4-BE49-F238E27FC236}">
-                <a16:creationId xmlns:a16="http://schemas.microsoft.com/office/drawing/2014/main" id="{AD5720B3-C2CE-4A65-BD2C-7F77063655BE}"/>
+                <a16:creationId xmlns:a16="http://schemas.microsoft.com/office/drawing/2014/main" id="{7BBEF541-FFCE-49D2-A518-DE06BE7E5FB4}"/>
               </a:ext>
             </a:extLst>
           </p:cNvPr>
@@ -23256,7 +23313,7 @@
     </p:spTree>
     <p:extLst>
       <p:ext uri="{BB962C8B-B14F-4D97-AF65-F5344CB8AC3E}">
-        <p14:creationId xmlns:p14="http://schemas.microsoft.com/office/powerpoint/2010/main" val="930968548"/>
+        <p14:creationId xmlns:p14="http://schemas.microsoft.com/office/powerpoint/2010/main" val="1048649978"/>
       </p:ext>
     </p:extLst>
   </p:cSld>
@@ -23287,7 +23344,7 @@
           <p:cNvPr id="6" name="">
             <a:extLst xmlns:a="http://schemas.openxmlformats.org/drawingml/2006/main">
               <a:ext uri="{FF2B5EF4-FFF2-40B4-BE49-F238E27FC236}">
-                <a16:creationId xmlns:a16="http://schemas.microsoft.com/office/drawing/2014/main" id="{C320A42B-AC34-4FDA-A746-7CB2A205C2D3}"/>
+                <a16:creationId xmlns:a16="http://schemas.microsoft.com/office/drawing/2014/main" id="{505A4047-EDDA-4DC6-953F-A2973016C9CD}"/>
               </a:ext>
             </a:extLst>
           </p:cNvPr>
@@ -23344,7 +23401,7 @@
           <p:cNvPr id="2" name="">
             <a:extLst xmlns:a="http://schemas.openxmlformats.org/drawingml/2006/main">
               <a:ext uri="{FF2B5EF4-FFF2-40B4-BE49-F238E27FC236}">
-                <a16:creationId xmlns:a16="http://schemas.microsoft.com/office/drawing/2014/main" id="{F0A32E9B-C690-470B-B86A-64F8C2EEB1A0}"/>
+                <a16:creationId xmlns:a16="http://schemas.microsoft.com/office/drawing/2014/main" id="{8E28351C-7A15-4734-99FC-7B11BFE7B77F}"/>
               </a:ext>
             </a:extLst>
           </p:cNvPr>
@@ -23401,7 +23458,7 @@
           <p:cNvPr id="3" name="">
             <a:extLst xmlns:a="http://schemas.openxmlformats.org/drawingml/2006/main">
               <a:ext uri="{FF2B5EF4-FFF2-40B4-BE49-F238E27FC236}">
-                <a16:creationId xmlns:a16="http://schemas.microsoft.com/office/drawing/2014/main" id="{F54A5A02-C261-4CCA-BF46-50E479E419FE}"/>
+                <a16:creationId xmlns:a16="http://schemas.microsoft.com/office/drawing/2014/main" id="{9013558F-E292-41C2-A77A-D2CFF3DBCD16}"/>
               </a:ext>
             </a:extLst>
           </p:cNvPr>
@@ -24337,7 +24394,7 @@
           <p:cNvPr id="5" name="">
             <a:extLst xmlns:a="http://schemas.openxmlformats.org/drawingml/2006/main">
               <a:ext uri="{FF2B5EF4-FFF2-40B4-BE49-F238E27FC236}">
-                <a16:creationId xmlns:a16="http://schemas.microsoft.com/office/drawing/2014/main" id="{8B0DD39E-B05F-44EE-98C7-8BF1574145BE}"/>
+                <a16:creationId xmlns:a16="http://schemas.microsoft.com/office/drawing/2014/main" id="{B25E55E4-E36D-4EB8-B43E-FE9B6230D7E8}"/>
               </a:ext>
             </a:extLst>
           </p:cNvPr>
@@ -24415,7 +24472,7 @@
     </p:spTree>
     <p:extLst>
       <p:ext uri="{BB962C8B-B14F-4D97-AF65-F5344CB8AC3E}">
-        <p14:creationId xmlns:p14="http://schemas.microsoft.com/office/powerpoint/2010/main" val="1115216777"/>
+        <p14:creationId xmlns:p14="http://schemas.microsoft.com/office/powerpoint/2010/main" val="1325967831"/>
       </p:ext>
     </p:extLst>
   </p:cSld>

</xml_diff>